<commit_message>
trained models and compared them. Now we need to dicsuss and align on the flow of the R code for feature
</commit_message>
<xml_diff>
--- a/Binary Classification 606.pptx
+++ b/Binary Classification 606.pptx
@@ -5,13 +5,15 @@
     <p:sldMasterId id="2147483648" r:id="rId1"/>
   </p:sldMasterIdLst>
   <p:notesMasterIdLst>
-    <p:notesMasterId r:id="rId6"/>
+    <p:notesMasterId r:id="rId8"/>
   </p:notesMasterIdLst>
   <p:sldIdLst>
     <p:sldId id="256" r:id="rId2"/>
     <p:sldId id="257" r:id="rId3"/>
     <p:sldId id="258" r:id="rId4"/>
-    <p:sldId id="259" r:id="rId5"/>
+    <p:sldId id="260" r:id="rId5"/>
+    <p:sldId id="259" r:id="rId6"/>
+    <p:sldId id="261" r:id="rId7"/>
   </p:sldIdLst>
   <p:sldSz cx="12192000" cy="6858000"/>
   <p:notesSz cx="6858000" cy="9144000"/>
@@ -200,7 +202,7 @@
           <a:p>
             <a:fld id="{F94E02D4-7CEE-4426-B842-C52CC7EAF1AF}" type="datetimeFigureOut">
               <a:rPr lang="en-ZA" smtClean="0"/>
-              <a:t>2026/04/27</a:t>
+              <a:t>2026/04/28</a:t>
             </a:fld>
             <a:endParaRPr lang="en-ZA"/>
           </a:p>
@@ -617,7 +619,7 @@
           <a:p>
             <a:fld id="{D3997BC2-908B-4AE2-B66B-0BE82B2F56FB}" type="datetimeFigureOut">
               <a:rPr lang="en-ZA" smtClean="0"/>
-              <a:t>2026/04/27</a:t>
+              <a:t>2026/04/28</a:t>
             </a:fld>
             <a:endParaRPr lang="en-ZA"/>
           </a:p>
@@ -817,7 +819,7 @@
           <a:p>
             <a:fld id="{D3997BC2-908B-4AE2-B66B-0BE82B2F56FB}" type="datetimeFigureOut">
               <a:rPr lang="en-ZA" smtClean="0"/>
-              <a:t>2026/04/27</a:t>
+              <a:t>2026/04/28</a:t>
             </a:fld>
             <a:endParaRPr lang="en-ZA"/>
           </a:p>
@@ -1027,7 +1029,7 @@
           <a:p>
             <a:fld id="{D3997BC2-908B-4AE2-B66B-0BE82B2F56FB}" type="datetimeFigureOut">
               <a:rPr lang="en-ZA" smtClean="0"/>
-              <a:t>2026/04/27</a:t>
+              <a:t>2026/04/28</a:t>
             </a:fld>
             <a:endParaRPr lang="en-ZA"/>
           </a:p>
@@ -1227,7 +1229,7 @@
           <a:p>
             <a:fld id="{D3997BC2-908B-4AE2-B66B-0BE82B2F56FB}" type="datetimeFigureOut">
               <a:rPr lang="en-ZA" smtClean="0"/>
-              <a:t>2026/04/27</a:t>
+              <a:t>2026/04/28</a:t>
             </a:fld>
             <a:endParaRPr lang="en-ZA"/>
           </a:p>
@@ -1503,7 +1505,7 @@
           <a:p>
             <a:fld id="{D3997BC2-908B-4AE2-B66B-0BE82B2F56FB}" type="datetimeFigureOut">
               <a:rPr lang="en-ZA" smtClean="0"/>
-              <a:t>2026/04/27</a:t>
+              <a:t>2026/04/28</a:t>
             </a:fld>
             <a:endParaRPr lang="en-ZA"/>
           </a:p>
@@ -1771,7 +1773,7 @@
           <a:p>
             <a:fld id="{D3997BC2-908B-4AE2-B66B-0BE82B2F56FB}" type="datetimeFigureOut">
               <a:rPr lang="en-ZA" smtClean="0"/>
-              <a:t>2026/04/27</a:t>
+              <a:t>2026/04/28</a:t>
             </a:fld>
             <a:endParaRPr lang="en-ZA"/>
           </a:p>
@@ -2186,7 +2188,7 @@
           <a:p>
             <a:fld id="{D3997BC2-908B-4AE2-B66B-0BE82B2F56FB}" type="datetimeFigureOut">
               <a:rPr lang="en-ZA" smtClean="0"/>
-              <a:t>2026/04/27</a:t>
+              <a:t>2026/04/28</a:t>
             </a:fld>
             <a:endParaRPr lang="en-ZA"/>
           </a:p>
@@ -2328,7 +2330,7 @@
           <a:p>
             <a:fld id="{D3997BC2-908B-4AE2-B66B-0BE82B2F56FB}" type="datetimeFigureOut">
               <a:rPr lang="en-ZA" smtClean="0"/>
-              <a:t>2026/04/27</a:t>
+              <a:t>2026/04/28</a:t>
             </a:fld>
             <a:endParaRPr lang="en-ZA"/>
           </a:p>
@@ -2441,7 +2443,7 @@
           <a:p>
             <a:fld id="{D3997BC2-908B-4AE2-B66B-0BE82B2F56FB}" type="datetimeFigureOut">
               <a:rPr lang="en-ZA" smtClean="0"/>
-              <a:t>2026/04/27</a:t>
+              <a:t>2026/04/28</a:t>
             </a:fld>
             <a:endParaRPr lang="en-ZA"/>
           </a:p>
@@ -2754,7 +2756,7 @@
           <a:p>
             <a:fld id="{D3997BC2-908B-4AE2-B66B-0BE82B2F56FB}" type="datetimeFigureOut">
               <a:rPr lang="en-ZA" smtClean="0"/>
-              <a:t>2026/04/27</a:t>
+              <a:t>2026/04/28</a:t>
             </a:fld>
             <a:endParaRPr lang="en-ZA"/>
           </a:p>
@@ -3043,7 +3045,7 @@
           <a:p>
             <a:fld id="{D3997BC2-908B-4AE2-B66B-0BE82B2F56FB}" type="datetimeFigureOut">
               <a:rPr lang="en-ZA" smtClean="0"/>
-              <a:t>2026/04/27</a:t>
+              <a:t>2026/04/28</a:t>
             </a:fld>
             <a:endParaRPr lang="en-ZA"/>
           </a:p>
@@ -3286,7 +3288,7 @@
           <a:p>
             <a:fld id="{D3997BC2-908B-4AE2-B66B-0BE82B2F56FB}" type="datetimeFigureOut">
               <a:rPr lang="en-ZA" smtClean="0"/>
-              <a:t>2026/04/27</a:t>
+              <a:t>2026/04/28</a:t>
             </a:fld>
             <a:endParaRPr lang="en-ZA"/>
           </a:p>
@@ -4409,7 +4411,7 @@
         </p:nvSpPr>
         <p:spPr>
           <a:xfrm>
-            <a:off x="228142" y="1142286"/>
+            <a:off x="212651" y="1061439"/>
             <a:ext cx="5465106" cy="5622029"/>
           </a:xfrm>
           <a:prstGeom prst="rect">
@@ -4609,7 +4611,7 @@
             </a:r>
             <a:r>
               <a:rPr lang="en-US" sz="1400" dirty="0"/>
-              <a:t> dataset from manufacturing operations.</a:t>
+              <a:t> dataset from manufacturing operations. </a:t>
             </a:r>
           </a:p>
           <a:p>
@@ -4618,7 +4620,7 @@
             </a:pPr>
             <a:r>
               <a:rPr lang="en-US" sz="1400" dirty="0"/>
-              <a:t>The dataset contains machine downtime events from PLC in </a:t>
+              <a:t>The dataset contains machine downtime events (features) from PLC in </a:t>
             </a:r>
             <a:r>
               <a:rPr lang="en-US" sz="1400" dirty="0" err="1"/>
@@ -4942,8 +4944,8 @@
         </p:nvSpPr>
         <p:spPr bwMode="auto">
           <a:xfrm>
-            <a:off x="5693248" y="991014"/>
-            <a:ext cx="5789570" cy="2200602"/>
+            <a:off x="5826436" y="999039"/>
+            <a:ext cx="5789570" cy="2846933"/>
           </a:xfrm>
           <a:prstGeom prst="rect">
             <a:avLst/>
@@ -5016,7 +5018,7 @@
                   <a:schemeClr val="tx1"/>
                 </a:solidFill>
                 <a:effectLst/>
-                <a:latin typeface="Arial" panose="020B0604020202020204" pitchFamily="34" charset="0"/>
+                <a:latin typeface="Aptos (Body)"/>
               </a:rPr>
               <a:t>Business Problem</a:t>
             </a:r>
@@ -5029,7 +5031,7 @@
                   <a:schemeClr val="tx1"/>
                 </a:solidFill>
                 <a:effectLst/>
-                <a:latin typeface="Arial" panose="020B0604020202020204" pitchFamily="34" charset="0"/>
+                <a:latin typeface="Aptos (Body)"/>
               </a:rPr>
             </a:br>
             <a:endParaRPr kumimoji="0" lang="en-US" altLang="en-US" sz="1400" b="1" i="0" u="none" strike="noStrike" cap="none" normalizeH="0" baseline="0" dirty="0">
@@ -5040,7 +5042,7 @@
                 <a:schemeClr val="tx1"/>
               </a:solidFill>
               <a:effectLst/>
-              <a:latin typeface="Arial" panose="020B0604020202020204" pitchFamily="34" charset="0"/>
+              <a:latin typeface="Aptos (Body)"/>
             </a:endParaRPr>
           </a:p>
           <a:p>
@@ -5069,13 +5071,13 @@
                   <a:schemeClr val="tx1"/>
                 </a:solidFill>
                 <a:effectLst/>
-                <a:latin typeface="Arial" panose="020B0604020202020204" pitchFamily="34" charset="0"/>
+                <a:latin typeface="Aptos (Body)"/>
               </a:rPr>
               <a:t>The objective is to </a:t>
             </a:r>
             <a:r>
               <a:rPr lang="en-US" altLang="en-US" sz="1400" dirty="0">
-                <a:latin typeface="Arial" panose="020B0604020202020204" pitchFamily="34" charset="0"/>
+                <a:latin typeface="Aptos (Body)"/>
               </a:rPr>
               <a:t>p</a:t>
             </a:r>
@@ -5088,9 +5090,9 @@
                   <a:schemeClr val="tx1"/>
                 </a:solidFill>
                 <a:effectLst/>
-                <a:latin typeface="Arial" panose="020B0604020202020204" pitchFamily="34" charset="0"/>
+                <a:latin typeface="Aptos (Body)"/>
               </a:rPr>
-              <a:t>redict whether vehicle machine downtime/failures require maintenance using historical downtime logs.</a:t>
+              <a:t>redict whether machine downtime/failures require maintenance using EMEA plants historical downtime logs.</a:t>
             </a:r>
           </a:p>
           <a:p>
@@ -5111,8 +5113,63 @@
               <a:tabLst/>
             </a:pPr>
             <a:endParaRPr lang="en-US" altLang="en-US" sz="1400" dirty="0">
-              <a:latin typeface="Arial" panose="020B0604020202020204" pitchFamily="34" charset="0"/>
+              <a:latin typeface="Aptos (Body)"/>
             </a:endParaRPr>
+          </a:p>
+          <a:p>
+            <a:pPr lvl="0" eaLnBrk="0" fontAlgn="base" hangingPunct="0">
+              <a:spcBef>
+                <a:spcPct val="0"/>
+              </a:spcBef>
+              <a:spcAft>
+                <a:spcPct val="0"/>
+              </a:spcAft>
+            </a:pPr>
+            <a:r>
+              <a:rPr kumimoji="0" lang="en-US" altLang="en-US" sz="1400" b="1" i="0" u="none" strike="noStrike" cap="none" normalizeH="0" baseline="0" dirty="0">
+                <a:ln>
+                  <a:noFill/>
+                </a:ln>
+                <a:solidFill>
+                  <a:schemeClr val="tx1"/>
+                </a:solidFill>
+                <a:effectLst/>
+                <a:latin typeface="Aptos (Body)"/>
+              </a:rPr>
+              <a:t>Goal</a:t>
+            </a:r>
+            <a:r>
+              <a:rPr kumimoji="0" lang="en-US" altLang="en-US" sz="1400" b="0" i="0" u="none" strike="noStrike" cap="none" normalizeH="0" baseline="0" dirty="0">
+                <a:ln>
+                  <a:noFill/>
+                </a:ln>
+                <a:solidFill>
+                  <a:schemeClr val="tx1"/>
+                </a:solidFill>
+                <a:effectLst/>
+                <a:latin typeface="Aptos (Body)"/>
+              </a:rPr>
+              <a:t>: </a:t>
+            </a:r>
+            <a:r>
+              <a:rPr lang="en-US" altLang="en-US" sz="1400" dirty="0">
+                <a:latin typeface="Aptos (Body)"/>
+              </a:rPr>
+              <a:t>Reduce unplanned downtime through early identification of maintenance needs</a:t>
+            </a:r>
+            <a:r>
+              <a:rPr kumimoji="0" lang="en-US" altLang="en-US" sz="1400" b="0" i="0" u="none" strike="noStrike" cap="none" normalizeH="0" baseline="0" dirty="0">
+                <a:ln>
+                  <a:noFill/>
+                </a:ln>
+                <a:solidFill>
+                  <a:schemeClr val="tx1"/>
+                </a:solidFill>
+                <a:effectLst/>
+                <a:latin typeface="Aptos (Body)"/>
+              </a:rPr>
+              <a:t>.</a:t>
+            </a:r>
           </a:p>
           <a:p>
             <a:pPr marL="0" marR="0" lvl="0" indent="0" algn="l" defTabSz="914400" rtl="0" eaLnBrk="0" fontAlgn="base" latinLnBrk="0" hangingPunct="0">
@@ -5131,6 +5188,27 @@
               <a:buNone/>
               <a:tabLst/>
             </a:pPr>
+            <a:endParaRPr lang="en-US" altLang="en-US" sz="1400" dirty="0">
+              <a:latin typeface="Aptos (Body)"/>
+            </a:endParaRPr>
+          </a:p>
+          <a:p>
+            <a:pPr marL="0" marR="0" lvl="0" indent="0" algn="l" defTabSz="914400" rtl="0" eaLnBrk="0" fontAlgn="base" latinLnBrk="0" hangingPunct="0">
+              <a:lnSpc>
+                <a:spcPct val="100000"/>
+              </a:lnSpc>
+              <a:spcBef>
+                <a:spcPct val="0"/>
+              </a:spcBef>
+              <a:spcAft>
+                <a:spcPct val="0"/>
+              </a:spcAft>
+              <a:buClrTx/>
+              <a:buSzTx/>
+              <a:buFontTx/>
+              <a:buNone/>
+              <a:tabLst/>
+            </a:pPr>
             <a:r>
               <a:rPr kumimoji="0" lang="en-US" altLang="en-US" sz="1400" b="0" i="0" u="none" strike="noStrike" cap="none" normalizeH="0" baseline="0" dirty="0">
                 <a:ln>
@@ -5140,7 +5218,7 @@
                   <a:schemeClr val="tx1"/>
                 </a:solidFill>
                 <a:effectLst/>
-                <a:latin typeface="Arial" panose="020B0604020202020204" pitchFamily="34" charset="0"/>
+                <a:latin typeface="Aptos (Body)"/>
               </a:rPr>
               <a:t>Binary classification problem: </a:t>
             </a:r>
@@ -5153,7 +5231,7 @@
                   <a:schemeClr val="tx1"/>
                 </a:solidFill>
                 <a:effectLst/>
-                <a:latin typeface="Arial" panose="020B0604020202020204" pitchFamily="34" charset="0"/>
+                <a:latin typeface="Aptos (Body)"/>
               </a:rPr>
               <a:t>MaintenanceRequired</a:t>
             </a:r>
@@ -5166,7 +5244,7 @@
                   <a:schemeClr val="tx1"/>
                 </a:solidFill>
                 <a:effectLst/>
-                <a:latin typeface="Arial" panose="020B0604020202020204" pitchFamily="34" charset="0"/>
+                <a:latin typeface="Aptos (Body)"/>
               </a:rPr>
               <a:t> (0/1)</a:t>
             </a:r>
@@ -5315,14 +5393,14 @@
           <p:nvPr>
             <p:extLst>
               <p:ext uri="{D42A27DB-BD31-4B8C-83A1-F6EECF244321}">
-                <p14:modId xmlns:p14="http://schemas.microsoft.com/office/powerpoint/2010/main" val="835158702"/>
+                <p14:modId xmlns:p14="http://schemas.microsoft.com/office/powerpoint/2010/main" val="2944102612"/>
               </p:ext>
             </p:extLst>
           </p:nvPr>
         </p:nvGraphicFramePr>
         <p:xfrm>
-          <a:off x="5854696" y="3125402"/>
-          <a:ext cx="5789570" cy="1170037"/>
+          <a:off x="5959624" y="3998115"/>
+          <a:ext cx="5789570" cy="1097280"/>
         </p:xfrm>
         <a:graphic>
           <a:graphicData uri="http://schemas.openxmlformats.org/drawingml/2006/table">
@@ -5346,7 +5424,7 @@
                   </a:extLst>
                 </a:gridCol>
               </a:tblGrid>
-              <a:tr h="368021">
+              <a:tr h="316173">
                 <a:tc>
                   <a:txBody>
                     <a:bodyPr/>
@@ -5385,7 +5463,7 @@
                   </a:ext>
                 </a:extLst>
               </a:tr>
-              <a:tr h="401008">
+              <a:tr h="316173">
                 <a:tc>
                   <a:txBody>
                     <a:bodyPr/>
@@ -5420,7 +5498,7 @@
                   </a:ext>
                 </a:extLst>
               </a:tr>
-              <a:tr h="401008">
+              <a:tr h="316173">
                 <a:tc>
                   <a:txBody>
                     <a:bodyPr/>
@@ -5535,8 +5613,8 @@
         </p:blipFill>
         <p:spPr bwMode="auto">
           <a:xfrm flipH="1">
-            <a:off x="5854696" y="4365101"/>
-            <a:ext cx="5789570" cy="2322320"/>
+            <a:off x="5959623" y="5156871"/>
+            <a:ext cx="5580990" cy="1644912"/>
           </a:xfrm>
           <a:prstGeom prst="rect">
             <a:avLst/>
@@ -6033,41 +6111,55 @@
           </a:lstStyle>
           <a:p>
             <a:r>
-              <a:rPr lang="en-US" sz="2900" dirty="0"/>
+              <a:rPr lang="en-US" sz="2400" dirty="0"/>
               <a:t>Duplicate removal: unique(</a:t>
             </a:r>
             <a:r>
-              <a:rPr lang="en-US" sz="2900" dirty="0" err="1"/>
+              <a:rPr lang="en-US" sz="2400" dirty="0" err="1"/>
               <a:t>df</a:t>
             </a:r>
             <a:r>
-              <a:rPr lang="en-US" sz="2900" dirty="0"/>
+              <a:rPr lang="en-US" sz="2400" dirty="0"/>
               <a:t>) used to eliminate repeated downtime records.</a:t>
             </a:r>
           </a:p>
           <a:p>
             <a:r>
-              <a:rPr lang="en-US" sz="2900" dirty="0"/>
+              <a:rPr lang="en-US" sz="2400" dirty="0"/>
               <a:t>Missing numeric values: imputed using median (robust to outliers).</a:t>
             </a:r>
           </a:p>
           <a:p>
             <a:r>
-              <a:rPr lang="en-US" sz="2900" dirty="0"/>
+              <a:rPr lang="en-US" sz="2400" dirty="0"/>
               <a:t>Missing categorical values: replaced with 'Unknown' category.</a:t>
             </a:r>
           </a:p>
           <a:p>
             <a:r>
-              <a:rPr lang="en-US" sz="2900" dirty="0"/>
+              <a:rPr lang="en-US" sz="2400" dirty="0"/>
+              <a:t>Fixed </a:t>
+            </a:r>
+            <a:r>
+              <a:rPr lang="en-US" sz="2400" dirty="0" err="1"/>
+              <a:t>NaN</a:t>
+            </a:r>
+            <a:r>
+              <a:rPr lang="en-US" sz="2400" dirty="0"/>
+              <a:t> and infinite values before modelling  our data in H2O environment</a:t>
+            </a:r>
+          </a:p>
+          <a:p>
+            <a:r>
+              <a:rPr lang="en-US" sz="2400" dirty="0"/>
               <a:t>High-cardinality identifiers removed (e.g., </a:t>
             </a:r>
             <a:r>
-              <a:rPr lang="en-US" sz="2900" dirty="0" err="1"/>
+              <a:rPr lang="en-US" sz="2400" dirty="0" err="1"/>
               <a:t>DowntimeId</a:t>
             </a:r>
             <a:r>
-              <a:rPr lang="en-US" sz="2900" dirty="0"/>
+              <a:rPr lang="en-US" sz="2400" dirty="0"/>
               <a:t>) to reduce noise.</a:t>
             </a:r>
           </a:p>
@@ -6075,48 +6167,75 @@
             <a:pPr marL="0" indent="0">
               <a:buNone/>
             </a:pPr>
-            <a:r>
-              <a:rPr lang="en-US" sz="2900" b="1" dirty="0">
+            <a:endParaRPr lang="en-US" sz="2400" dirty="0"/>
+          </a:p>
+          <a:p>
+            <a:pPr marL="0" indent="0">
+              <a:buNone/>
+            </a:pPr>
+            <a:r>
+              <a:rPr lang="en-US" sz="2400" b="1" dirty="0">
                 <a:solidFill>
                   <a:srgbClr val="C00000"/>
                 </a:solidFill>
                 <a:latin typeface="Aptos (Body)"/>
               </a:rPr>
-              <a:t>Feature Engineering</a:t>
-            </a:r>
-          </a:p>
-          <a:p>
-            <a:r>
-              <a:rPr lang="en-US" sz="2900" dirty="0"/>
+              <a:t>Feature Engineering </a:t>
+            </a:r>
+            <a:r>
+              <a:rPr lang="en-US" sz="2400" b="1" dirty="0">
+                <a:latin typeface="Aptos (Body)"/>
+              </a:rPr>
+              <a:t>(</a:t>
+            </a:r>
+            <a:r>
+              <a:rPr lang="en-US" sz="2400" b="1" dirty="0"/>
+              <a:t>Purpose: Improve model ability to capture operational </a:t>
+            </a:r>
+            <a:r>
+              <a:rPr lang="en-US" sz="2400" b="1" dirty="0" err="1"/>
+              <a:t>behaviour</a:t>
+            </a:r>
+            <a:r>
+              <a:rPr lang="en-US" sz="2400" b="1" dirty="0"/>
+              <a:t> patterns)</a:t>
+            </a:r>
+            <a:endParaRPr lang="en-US" sz="2400" b="1" dirty="0">
+              <a:latin typeface="Aptos (Body)"/>
+            </a:endParaRPr>
+          </a:p>
+          <a:p>
+            <a:r>
+              <a:rPr lang="en-US" sz="2400" dirty="0"/>
               <a:t>Target creation: based on median downtime threshold + failure keywords.</a:t>
             </a:r>
           </a:p>
           <a:p>
             <a:r>
-              <a:rPr lang="en-US" sz="2900" dirty="0"/>
+              <a:rPr lang="en-US" sz="2400" dirty="0"/>
               <a:t>New features: Hour extracted from timestamp, </a:t>
             </a:r>
             <a:r>
-              <a:rPr lang="en-US" sz="2900" dirty="0" err="1"/>
+              <a:rPr lang="en-US" sz="2400" dirty="0" err="1"/>
               <a:t>DayOfWeek</a:t>
             </a:r>
             <a:r>
-              <a:rPr lang="en-US" sz="2900" dirty="0"/>
+              <a:rPr lang="en-US" sz="2400" dirty="0"/>
               <a:t> derived from date.</a:t>
             </a:r>
           </a:p>
           <a:p>
             <a:r>
-              <a:rPr lang="en-US" sz="2900" dirty="0" err="1"/>
+              <a:rPr lang="en-US" sz="2400" dirty="0" err="1"/>
               <a:t>EmergencyFlag</a:t>
             </a:r>
             <a:r>
-              <a:rPr lang="en-US" sz="2900" dirty="0"/>
+              <a:rPr lang="en-US" sz="2400" dirty="0"/>
               <a:t> created using keyword detection (emergency, critical, urgent).</a:t>
             </a:r>
           </a:p>
           <a:p>
-            <a:endParaRPr lang="en-US" sz="2900" dirty="0"/>
+            <a:endParaRPr lang="en-US" sz="2400" dirty="0"/>
           </a:p>
         </p:txBody>
       </p:sp>
@@ -6304,7 +6423,7 @@
         <p:cNvPr id="1" name="">
           <a:extLst>
             <a:ext uri="{FF2B5EF4-FFF2-40B4-BE49-F238E27FC236}">
-              <a16:creationId xmlns:a16="http://schemas.microsoft.com/office/drawing/2014/main" id="{EBEA84AA-879B-1608-E5B0-DADF5BEADB56}"/>
+              <a16:creationId xmlns:a16="http://schemas.microsoft.com/office/drawing/2014/main" id="{63D2DD76-0BB7-AF9B-7A0C-6FF4317D33FF}"/>
             </a:ext>
           </a:extLst>
         </p:cNvPr>
@@ -6324,7 +6443,7 @@
           <p:cNvPr id="2" name="Picture 1">
             <a:extLst>
               <a:ext uri="{FF2B5EF4-FFF2-40B4-BE49-F238E27FC236}">
-                <a16:creationId xmlns:a16="http://schemas.microsoft.com/office/drawing/2014/main" id="{261AC087-A4BC-5BB7-5663-D862D79BC19D}"/>
+                <a16:creationId xmlns:a16="http://schemas.microsoft.com/office/drawing/2014/main" id="{85785022-2A51-E743-30DB-23E51EA76DA3}"/>
               </a:ext>
             </a:extLst>
           </p:cNvPr>
@@ -6360,7 +6479,7 @@
           <p:cNvPr id="3" name="Content Placeholder 2">
             <a:extLst>
               <a:ext uri="{FF2B5EF4-FFF2-40B4-BE49-F238E27FC236}">
-                <a16:creationId xmlns:a16="http://schemas.microsoft.com/office/drawing/2014/main" id="{43070995-D11D-90BC-C0B5-4A9F4737ECAB}"/>
+                <a16:creationId xmlns:a16="http://schemas.microsoft.com/office/drawing/2014/main" id="{585007F7-0919-A9D0-BEC1-DE8E4A3DF211}"/>
               </a:ext>
             </a:extLst>
           </p:cNvPr>
@@ -6564,8 +6683,9 @@
                 <a:solidFill>
                   <a:srgbClr val="C00000"/>
                 </a:solidFill>
+                <a:latin typeface="Aptos (Body)"/>
               </a:rPr>
-              <a:t>Train/Test Split &amp; Model Stability</a:t>
+              <a:t>4. Machine Learning Models</a:t>
             </a:r>
           </a:p>
         </p:txBody>
@@ -6575,7 +6695,7 @@
           <p:cNvPr id="4" name="Content Placeholder 2">
             <a:extLst>
               <a:ext uri="{FF2B5EF4-FFF2-40B4-BE49-F238E27FC236}">
-                <a16:creationId xmlns:a16="http://schemas.microsoft.com/office/drawing/2014/main" id="{7E7EBEC9-BC9B-FA34-18A3-BAD0D0C5542C}"/>
+                <a16:creationId xmlns:a16="http://schemas.microsoft.com/office/drawing/2014/main" id="{173A6AC1-F31E-0E11-46C7-2E21ED3AAAFE}"/>
               </a:ext>
             </a:extLst>
           </p:cNvPr>
@@ -6762,44 +6882,71 @@
             </a:lvl9pPr>
           </a:lstStyle>
           <a:p>
-            <a:r>
-              <a:rPr lang="en-US" sz="3200" dirty="0"/>
-              <a:t>Used 70:30 split ensuring class representation.</a:t>
-            </a:r>
-          </a:p>
-          <a:p>
-            <a:r>
-              <a:rPr lang="en-US" sz="3200" dirty="0"/>
-              <a:t>Stratified split via </a:t>
-            </a:r>
-            <a:r>
-              <a:rPr lang="en-US" sz="3200" dirty="0" err="1"/>
-              <a:t>createDataPartition</a:t>
-            </a:r>
-            <a:r>
-              <a:rPr lang="en-US" sz="3200" dirty="0"/>
-              <a:t> to avoid missing class issues.</a:t>
-            </a:r>
-          </a:p>
-          <a:p>
-            <a:r>
-              <a:rPr lang="en-US" sz="3200" dirty="0"/>
-              <a:t>Models: Logistic Regression, Decision Tree (</a:t>
-            </a:r>
-            <a:r>
-              <a:rPr lang="en-US" sz="3200" dirty="0" err="1"/>
-              <a:t>rpart</a:t>
-            </a:r>
-            <a:r>
-              <a:rPr lang="en-US" sz="3200" dirty="0"/>
-              <a:t>), Naive Bayes (H2O), Random Forest/GBM.</a:t>
-            </a:r>
-          </a:p>
-          <a:p>
-            <a:r>
-              <a:rPr lang="en-US" sz="3200" dirty="0"/>
-              <a:t>Evaluation metric: AUC due to class imbalance.</a:t>
-            </a:r>
+            <a:pPr>
+              <a:lnSpc>
+                <a:spcPct val="150000"/>
+              </a:lnSpc>
+            </a:pPr>
+            <a:r>
+              <a:rPr lang="en-US" b="1" dirty="0"/>
+              <a:t>Four classification techniques were applied:</a:t>
+            </a:r>
+          </a:p>
+          <a:p>
+            <a:pPr marL="0" indent="0">
+              <a:lnSpc>
+                <a:spcPct val="150000"/>
+              </a:lnSpc>
+              <a:buNone/>
+            </a:pPr>
+            <a:r>
+              <a:rPr lang="en-US" dirty="0"/>
+              <a:t>- Decision Tree (interpretable rule-based model)</a:t>
+            </a:r>
+          </a:p>
+          <a:p>
+            <a:pPr marL="0" indent="0">
+              <a:lnSpc>
+                <a:spcPct val="150000"/>
+              </a:lnSpc>
+              <a:buNone/>
+            </a:pPr>
+            <a:r>
+              <a:rPr lang="en-US" dirty="0"/>
+              <a:t>- Logistic Regression (linear baseline model)</a:t>
+            </a:r>
+          </a:p>
+          <a:p>
+            <a:pPr marL="0" indent="0">
+              <a:lnSpc>
+                <a:spcPct val="150000"/>
+              </a:lnSpc>
+              <a:buNone/>
+            </a:pPr>
+            <a:r>
+              <a:rPr lang="en-US" dirty="0"/>
+              <a:t>- Random Forest (ensemble model for improved accuracy)</a:t>
+            </a:r>
+          </a:p>
+          <a:p>
+            <a:pPr>
+              <a:lnSpc>
+                <a:spcPct val="150000"/>
+              </a:lnSpc>
+              <a:buFontTx/>
+              <a:buChar char="-"/>
+            </a:pPr>
+            <a:r>
+              <a:rPr lang="en-US" dirty="0"/>
+              <a:t>Naive Bayes (probabilistic independence model)</a:t>
+            </a:r>
+            <a:endParaRPr lang="en-US" b="1" dirty="0"/>
+          </a:p>
+          <a:p>
+            <a:pPr marL="0" indent="0">
+              <a:buNone/>
+            </a:pPr>
+            <a:endParaRPr lang="en-US" dirty="0"/>
           </a:p>
         </p:txBody>
       </p:sp>
@@ -6808,7 +6955,7 @@
           <p:cNvPr id="5" name="Rectangle 4">
             <a:extLst>
               <a:ext uri="{FF2B5EF4-FFF2-40B4-BE49-F238E27FC236}">
-                <a16:creationId xmlns:a16="http://schemas.microsoft.com/office/drawing/2014/main" id="{E7878C51-FD5E-8CE0-5298-5228D34465DB}"/>
+                <a16:creationId xmlns:a16="http://schemas.microsoft.com/office/drawing/2014/main" id="{14D316CE-BA63-4585-DFB7-6EC3F4566F73}"/>
               </a:ext>
             </a:extLst>
           </p:cNvPr>
@@ -6891,7 +7038,7 @@
           <p:cNvPr id="6" name="Straight Connector 5">
             <a:extLst>
               <a:ext uri="{FF2B5EF4-FFF2-40B4-BE49-F238E27FC236}">
-                <a16:creationId xmlns:a16="http://schemas.microsoft.com/office/drawing/2014/main" id="{57A5BBC0-16CE-8326-181A-F4F58F9585CF}"/>
+                <a16:creationId xmlns:a16="http://schemas.microsoft.com/office/drawing/2014/main" id="{38C8983E-0F76-F997-D466-989AFF980191}"/>
               </a:ext>
             </a:extLst>
           </p:cNvPr>
@@ -6936,7 +7083,7 @@
           <p:cNvPr id="8" name="TextBox 7">
             <a:extLst>
               <a:ext uri="{FF2B5EF4-FFF2-40B4-BE49-F238E27FC236}">
-                <a16:creationId xmlns:a16="http://schemas.microsoft.com/office/drawing/2014/main" id="{6396D213-E2C4-B2ED-9A6C-1C25A3CE606A}"/>
+                <a16:creationId xmlns:a16="http://schemas.microsoft.com/office/drawing/2014/main" id="{F3B4A22E-AF75-104F-14D6-3BF7281A3923}"/>
               </a:ext>
             </a:extLst>
           </p:cNvPr>
@@ -6969,7 +7116,1458 @@
     </p:spTree>
     <p:extLst>
       <p:ext uri="{BB962C8B-B14F-4D97-AF65-F5344CB8AC3E}">
+        <p14:creationId xmlns:p14="http://schemas.microsoft.com/office/powerpoint/2010/main" val="1298775108"/>
+      </p:ext>
+    </p:extLst>
+  </p:cSld>
+  <p:clrMapOvr>
+    <a:masterClrMapping/>
+  </p:clrMapOvr>
+</p:sld>
+</file>
+
+<file path=ppt/slides/slide5.xml><?xml version="1.0" encoding="utf-8"?>
+<p:sld xmlns:a="http://schemas.openxmlformats.org/drawingml/2006/main" xmlns:r="http://schemas.openxmlformats.org/officeDocument/2006/relationships" xmlns:p="http://schemas.openxmlformats.org/presentationml/2006/main">
+  <p:cSld>
+    <p:spTree>
+      <p:nvGrpSpPr>
+        <p:cNvPr id="1" name="">
+          <a:extLst>
+            <a:ext uri="{FF2B5EF4-FFF2-40B4-BE49-F238E27FC236}">
+              <a16:creationId xmlns:a16="http://schemas.microsoft.com/office/drawing/2014/main" id="{EBEA84AA-879B-1608-E5B0-DADF5BEADB56}"/>
+            </a:ext>
+          </a:extLst>
+        </p:cNvPr>
+        <p:cNvGrpSpPr/>
+        <p:nvPr/>
+      </p:nvGrpSpPr>
+      <p:grpSpPr>
+        <a:xfrm>
+          <a:off x="0" y="0"/>
+          <a:ext cx="0" cy="0"/>
+          <a:chOff x="0" y="0"/>
+          <a:chExt cx="0" cy="0"/>
+        </a:xfrm>
+      </p:grpSpPr>
+      <p:pic>
+        <p:nvPicPr>
+          <p:cNvPr id="2" name="Picture 1">
+            <a:extLst>
+              <a:ext uri="{FF2B5EF4-FFF2-40B4-BE49-F238E27FC236}">
+                <a16:creationId xmlns:a16="http://schemas.microsoft.com/office/drawing/2014/main" id="{261AC087-A4BC-5BB7-5663-D862D79BC19D}"/>
+              </a:ext>
+            </a:extLst>
+          </p:cNvPr>
+          <p:cNvPicPr>
+            <a:picLocks noChangeAspect="1"/>
+          </p:cNvPicPr>
+          <p:nvPr/>
+        </p:nvPicPr>
+        <p:blipFill>
+          <a:blip r:embed="rId2" cstate="print">
+            <a:extLst>
+              <a:ext uri="{28A0092B-C50C-407E-A947-70E740481C1C}">
+                <a14:useLocalDpi xmlns:a14="http://schemas.microsoft.com/office/drawing/2010/main" val="0"/>
+              </a:ext>
+            </a:extLst>
+          </a:blip>
+          <a:stretch>
+            <a:fillRect/>
+          </a:stretch>
+        </p:blipFill>
+        <p:spPr>
+          <a:xfrm>
+            <a:off x="9902951" y="170579"/>
+            <a:ext cx="2048257" cy="747614"/>
+          </a:xfrm>
+          <a:prstGeom prst="rect">
+            <a:avLst/>
+          </a:prstGeom>
+        </p:spPr>
+      </p:pic>
+      <p:sp>
+        <p:nvSpPr>
+          <p:cNvPr id="3" name="Content Placeholder 2">
+            <a:extLst>
+              <a:ext uri="{FF2B5EF4-FFF2-40B4-BE49-F238E27FC236}">
+                <a16:creationId xmlns:a16="http://schemas.microsoft.com/office/drawing/2014/main" id="{43070995-D11D-90BC-C0B5-4A9F4737ECAB}"/>
+              </a:ext>
+            </a:extLst>
+          </p:cNvPr>
+          <p:cNvSpPr txBox="1">
+            <a:spLocks/>
+          </p:cNvSpPr>
+          <p:nvPr/>
+        </p:nvSpPr>
+        <p:spPr>
+          <a:xfrm>
+            <a:off x="403504" y="415048"/>
+            <a:ext cx="9271437" cy="420682"/>
+          </a:xfrm>
+          <a:prstGeom prst="rect">
+            <a:avLst/>
+          </a:prstGeom>
+        </p:spPr>
+        <p:txBody>
+          <a:bodyPr>
+            <a:noAutofit/>
+          </a:bodyPr>
+          <a:lstStyle>
+            <a:lvl1pPr marL="228600" indent="-228600" algn="l" defTabSz="914400" rtl="0" eaLnBrk="1" latinLnBrk="0" hangingPunct="1">
+              <a:lnSpc>
+                <a:spcPct val="90000"/>
+              </a:lnSpc>
+              <a:spcBef>
+                <a:spcPts val="1000"/>
+              </a:spcBef>
+              <a:buFont typeface="Arial" panose="020B0604020202020204" pitchFamily="34" charset="0"/>
+              <a:buChar char="•"/>
+              <a:defRPr sz="2800" kern="1200">
+                <a:solidFill>
+                  <a:schemeClr val="tx1"/>
+                </a:solidFill>
+                <a:latin typeface="+mn-lt"/>
+                <a:ea typeface="+mn-ea"/>
+                <a:cs typeface="+mn-cs"/>
+              </a:defRPr>
+            </a:lvl1pPr>
+            <a:lvl2pPr marL="685800" indent="-228600" algn="l" defTabSz="914400" rtl="0" eaLnBrk="1" latinLnBrk="0" hangingPunct="1">
+              <a:lnSpc>
+                <a:spcPct val="90000"/>
+              </a:lnSpc>
+              <a:spcBef>
+                <a:spcPts val="500"/>
+              </a:spcBef>
+              <a:buFont typeface="Arial" panose="020B0604020202020204" pitchFamily="34" charset="0"/>
+              <a:buChar char="•"/>
+              <a:defRPr sz="2400" kern="1200">
+                <a:solidFill>
+                  <a:schemeClr val="tx1"/>
+                </a:solidFill>
+                <a:latin typeface="+mn-lt"/>
+                <a:ea typeface="+mn-ea"/>
+                <a:cs typeface="+mn-cs"/>
+              </a:defRPr>
+            </a:lvl2pPr>
+            <a:lvl3pPr marL="1143000" indent="-228600" algn="l" defTabSz="914400" rtl="0" eaLnBrk="1" latinLnBrk="0" hangingPunct="1">
+              <a:lnSpc>
+                <a:spcPct val="90000"/>
+              </a:lnSpc>
+              <a:spcBef>
+                <a:spcPts val="500"/>
+              </a:spcBef>
+              <a:buFont typeface="Arial" panose="020B0604020202020204" pitchFamily="34" charset="0"/>
+              <a:buChar char="•"/>
+              <a:defRPr sz="2000" kern="1200">
+                <a:solidFill>
+                  <a:schemeClr val="tx1"/>
+                </a:solidFill>
+                <a:latin typeface="+mn-lt"/>
+                <a:ea typeface="+mn-ea"/>
+                <a:cs typeface="+mn-cs"/>
+              </a:defRPr>
+            </a:lvl3pPr>
+            <a:lvl4pPr marL="1600200" indent="-228600" algn="l" defTabSz="914400" rtl="0" eaLnBrk="1" latinLnBrk="0" hangingPunct="1">
+              <a:lnSpc>
+                <a:spcPct val="90000"/>
+              </a:lnSpc>
+              <a:spcBef>
+                <a:spcPts val="500"/>
+              </a:spcBef>
+              <a:buFont typeface="Arial" panose="020B0604020202020204" pitchFamily="34" charset="0"/>
+              <a:buChar char="•"/>
+              <a:defRPr sz="1800" kern="1200">
+                <a:solidFill>
+                  <a:schemeClr val="tx1"/>
+                </a:solidFill>
+                <a:latin typeface="+mn-lt"/>
+                <a:ea typeface="+mn-ea"/>
+                <a:cs typeface="+mn-cs"/>
+              </a:defRPr>
+            </a:lvl4pPr>
+            <a:lvl5pPr marL="2057400" indent="-228600" algn="l" defTabSz="914400" rtl="0" eaLnBrk="1" latinLnBrk="0" hangingPunct="1">
+              <a:lnSpc>
+                <a:spcPct val="90000"/>
+              </a:lnSpc>
+              <a:spcBef>
+                <a:spcPts val="500"/>
+              </a:spcBef>
+              <a:buFont typeface="Arial" panose="020B0604020202020204" pitchFamily="34" charset="0"/>
+              <a:buChar char="•"/>
+              <a:defRPr sz="1800" kern="1200">
+                <a:solidFill>
+                  <a:schemeClr val="tx1"/>
+                </a:solidFill>
+                <a:latin typeface="+mn-lt"/>
+                <a:ea typeface="+mn-ea"/>
+                <a:cs typeface="+mn-cs"/>
+              </a:defRPr>
+            </a:lvl5pPr>
+            <a:lvl6pPr marL="2514600" indent="-228600" algn="l" defTabSz="914400" rtl="0" eaLnBrk="1" latinLnBrk="0" hangingPunct="1">
+              <a:lnSpc>
+                <a:spcPct val="90000"/>
+              </a:lnSpc>
+              <a:spcBef>
+                <a:spcPts val="500"/>
+              </a:spcBef>
+              <a:buFont typeface="Arial" panose="020B0604020202020204" pitchFamily="34" charset="0"/>
+              <a:buChar char="•"/>
+              <a:defRPr sz="1800" kern="1200">
+                <a:solidFill>
+                  <a:schemeClr val="tx1"/>
+                </a:solidFill>
+                <a:latin typeface="+mn-lt"/>
+                <a:ea typeface="+mn-ea"/>
+                <a:cs typeface="+mn-cs"/>
+              </a:defRPr>
+            </a:lvl6pPr>
+            <a:lvl7pPr marL="2971800" indent="-228600" algn="l" defTabSz="914400" rtl="0" eaLnBrk="1" latinLnBrk="0" hangingPunct="1">
+              <a:lnSpc>
+                <a:spcPct val="90000"/>
+              </a:lnSpc>
+              <a:spcBef>
+                <a:spcPts val="500"/>
+              </a:spcBef>
+              <a:buFont typeface="Arial" panose="020B0604020202020204" pitchFamily="34" charset="0"/>
+              <a:buChar char="•"/>
+              <a:defRPr sz="1800" kern="1200">
+                <a:solidFill>
+                  <a:schemeClr val="tx1"/>
+                </a:solidFill>
+                <a:latin typeface="+mn-lt"/>
+                <a:ea typeface="+mn-ea"/>
+                <a:cs typeface="+mn-cs"/>
+              </a:defRPr>
+            </a:lvl7pPr>
+            <a:lvl8pPr marL="3429000" indent="-228600" algn="l" defTabSz="914400" rtl="0" eaLnBrk="1" latinLnBrk="0" hangingPunct="1">
+              <a:lnSpc>
+                <a:spcPct val="90000"/>
+              </a:lnSpc>
+              <a:spcBef>
+                <a:spcPts val="500"/>
+              </a:spcBef>
+              <a:buFont typeface="Arial" panose="020B0604020202020204" pitchFamily="34" charset="0"/>
+              <a:buChar char="•"/>
+              <a:defRPr sz="1800" kern="1200">
+                <a:solidFill>
+                  <a:schemeClr val="tx1"/>
+                </a:solidFill>
+                <a:latin typeface="+mn-lt"/>
+                <a:ea typeface="+mn-ea"/>
+                <a:cs typeface="+mn-cs"/>
+              </a:defRPr>
+            </a:lvl8pPr>
+            <a:lvl9pPr marL="3886200" indent="-228600" algn="l" defTabSz="914400" rtl="0" eaLnBrk="1" latinLnBrk="0" hangingPunct="1">
+              <a:lnSpc>
+                <a:spcPct val="90000"/>
+              </a:lnSpc>
+              <a:spcBef>
+                <a:spcPts val="500"/>
+              </a:spcBef>
+              <a:buFont typeface="Arial" panose="020B0604020202020204" pitchFamily="34" charset="0"/>
+              <a:buChar char="•"/>
+              <a:defRPr sz="1800" kern="1200">
+                <a:solidFill>
+                  <a:schemeClr val="tx1"/>
+                </a:solidFill>
+                <a:latin typeface="+mn-lt"/>
+                <a:ea typeface="+mn-ea"/>
+                <a:cs typeface="+mn-cs"/>
+              </a:defRPr>
+            </a:lvl9pPr>
+          </a:lstStyle>
+          <a:p>
+            <a:pPr marL="0" indent="0">
+              <a:lnSpc>
+                <a:spcPts val="2900"/>
+              </a:lnSpc>
+              <a:spcBef>
+                <a:spcPts val="0"/>
+              </a:spcBef>
+              <a:spcAft>
+                <a:spcPts val="600"/>
+              </a:spcAft>
+              <a:buNone/>
+            </a:pPr>
+            <a:r>
+              <a:rPr lang="en-US" b="1" dirty="0">
+                <a:solidFill>
+                  <a:srgbClr val="C00000"/>
+                </a:solidFill>
+              </a:rPr>
+              <a:t>Model Evaluation &amp; Results</a:t>
+            </a:r>
+          </a:p>
+        </p:txBody>
+      </p:sp>
+      <p:sp>
+        <p:nvSpPr>
+          <p:cNvPr id="4" name="Content Placeholder 2">
+            <a:extLst>
+              <a:ext uri="{FF2B5EF4-FFF2-40B4-BE49-F238E27FC236}">
+                <a16:creationId xmlns:a16="http://schemas.microsoft.com/office/drawing/2014/main" id="{7E7EBEC9-BC9B-FA34-18A3-BAD0D0C5542C}"/>
+              </a:ext>
+            </a:extLst>
+          </p:cNvPr>
+          <p:cNvSpPr txBox="1">
+            <a:spLocks/>
+          </p:cNvSpPr>
+          <p:nvPr/>
+        </p:nvSpPr>
+        <p:spPr>
+          <a:xfrm>
+            <a:off x="228142" y="1142286"/>
+            <a:ext cx="11707462" cy="5622029"/>
+          </a:xfrm>
+          <a:prstGeom prst="rect">
+            <a:avLst/>
+          </a:prstGeom>
+        </p:spPr>
+        <p:txBody>
+          <a:bodyPr>
+            <a:noAutofit/>
+          </a:bodyPr>
+          <a:lstStyle>
+            <a:lvl1pPr marL="228600" indent="-228600" algn="l" defTabSz="914400" rtl="0" eaLnBrk="1" latinLnBrk="0" hangingPunct="1">
+              <a:lnSpc>
+                <a:spcPct val="90000"/>
+              </a:lnSpc>
+              <a:spcBef>
+                <a:spcPts val="1000"/>
+              </a:spcBef>
+              <a:buFont typeface="Arial" panose="020B0604020202020204" pitchFamily="34" charset="0"/>
+              <a:buChar char="•"/>
+              <a:defRPr sz="2800" kern="1200">
+                <a:solidFill>
+                  <a:schemeClr val="tx1"/>
+                </a:solidFill>
+                <a:latin typeface="+mn-lt"/>
+                <a:ea typeface="+mn-ea"/>
+                <a:cs typeface="+mn-cs"/>
+              </a:defRPr>
+            </a:lvl1pPr>
+            <a:lvl2pPr marL="685800" indent="-228600" algn="l" defTabSz="914400" rtl="0" eaLnBrk="1" latinLnBrk="0" hangingPunct="1">
+              <a:lnSpc>
+                <a:spcPct val="90000"/>
+              </a:lnSpc>
+              <a:spcBef>
+                <a:spcPts val="500"/>
+              </a:spcBef>
+              <a:buFont typeface="Arial" panose="020B0604020202020204" pitchFamily="34" charset="0"/>
+              <a:buChar char="•"/>
+              <a:defRPr sz="2400" kern="1200">
+                <a:solidFill>
+                  <a:schemeClr val="tx1"/>
+                </a:solidFill>
+                <a:latin typeface="+mn-lt"/>
+                <a:ea typeface="+mn-ea"/>
+                <a:cs typeface="+mn-cs"/>
+              </a:defRPr>
+            </a:lvl2pPr>
+            <a:lvl3pPr marL="1143000" indent="-228600" algn="l" defTabSz="914400" rtl="0" eaLnBrk="1" latinLnBrk="0" hangingPunct="1">
+              <a:lnSpc>
+                <a:spcPct val="90000"/>
+              </a:lnSpc>
+              <a:spcBef>
+                <a:spcPts val="500"/>
+              </a:spcBef>
+              <a:buFont typeface="Arial" panose="020B0604020202020204" pitchFamily="34" charset="0"/>
+              <a:buChar char="•"/>
+              <a:defRPr sz="2000" kern="1200">
+                <a:solidFill>
+                  <a:schemeClr val="tx1"/>
+                </a:solidFill>
+                <a:latin typeface="+mn-lt"/>
+                <a:ea typeface="+mn-ea"/>
+                <a:cs typeface="+mn-cs"/>
+              </a:defRPr>
+            </a:lvl3pPr>
+            <a:lvl4pPr marL="1600200" indent="-228600" algn="l" defTabSz="914400" rtl="0" eaLnBrk="1" latinLnBrk="0" hangingPunct="1">
+              <a:lnSpc>
+                <a:spcPct val="90000"/>
+              </a:lnSpc>
+              <a:spcBef>
+                <a:spcPts val="500"/>
+              </a:spcBef>
+              <a:buFont typeface="Arial" panose="020B0604020202020204" pitchFamily="34" charset="0"/>
+              <a:buChar char="•"/>
+              <a:defRPr sz="1800" kern="1200">
+                <a:solidFill>
+                  <a:schemeClr val="tx1"/>
+                </a:solidFill>
+                <a:latin typeface="+mn-lt"/>
+                <a:ea typeface="+mn-ea"/>
+                <a:cs typeface="+mn-cs"/>
+              </a:defRPr>
+            </a:lvl4pPr>
+            <a:lvl5pPr marL="2057400" indent="-228600" algn="l" defTabSz="914400" rtl="0" eaLnBrk="1" latinLnBrk="0" hangingPunct="1">
+              <a:lnSpc>
+                <a:spcPct val="90000"/>
+              </a:lnSpc>
+              <a:spcBef>
+                <a:spcPts val="500"/>
+              </a:spcBef>
+              <a:buFont typeface="Arial" panose="020B0604020202020204" pitchFamily="34" charset="0"/>
+              <a:buChar char="•"/>
+              <a:defRPr sz="1800" kern="1200">
+                <a:solidFill>
+                  <a:schemeClr val="tx1"/>
+                </a:solidFill>
+                <a:latin typeface="+mn-lt"/>
+                <a:ea typeface="+mn-ea"/>
+                <a:cs typeface="+mn-cs"/>
+              </a:defRPr>
+            </a:lvl5pPr>
+            <a:lvl6pPr marL="2514600" indent="-228600" algn="l" defTabSz="914400" rtl="0" eaLnBrk="1" latinLnBrk="0" hangingPunct="1">
+              <a:lnSpc>
+                <a:spcPct val="90000"/>
+              </a:lnSpc>
+              <a:spcBef>
+                <a:spcPts val="500"/>
+              </a:spcBef>
+              <a:buFont typeface="Arial" panose="020B0604020202020204" pitchFamily="34" charset="0"/>
+              <a:buChar char="•"/>
+              <a:defRPr sz="1800" kern="1200">
+                <a:solidFill>
+                  <a:schemeClr val="tx1"/>
+                </a:solidFill>
+                <a:latin typeface="+mn-lt"/>
+                <a:ea typeface="+mn-ea"/>
+                <a:cs typeface="+mn-cs"/>
+              </a:defRPr>
+            </a:lvl6pPr>
+            <a:lvl7pPr marL="2971800" indent="-228600" algn="l" defTabSz="914400" rtl="0" eaLnBrk="1" latinLnBrk="0" hangingPunct="1">
+              <a:lnSpc>
+                <a:spcPct val="90000"/>
+              </a:lnSpc>
+              <a:spcBef>
+                <a:spcPts val="500"/>
+              </a:spcBef>
+              <a:buFont typeface="Arial" panose="020B0604020202020204" pitchFamily="34" charset="0"/>
+              <a:buChar char="•"/>
+              <a:defRPr sz="1800" kern="1200">
+                <a:solidFill>
+                  <a:schemeClr val="tx1"/>
+                </a:solidFill>
+                <a:latin typeface="+mn-lt"/>
+                <a:ea typeface="+mn-ea"/>
+                <a:cs typeface="+mn-cs"/>
+              </a:defRPr>
+            </a:lvl7pPr>
+            <a:lvl8pPr marL="3429000" indent="-228600" algn="l" defTabSz="914400" rtl="0" eaLnBrk="1" latinLnBrk="0" hangingPunct="1">
+              <a:lnSpc>
+                <a:spcPct val="90000"/>
+              </a:lnSpc>
+              <a:spcBef>
+                <a:spcPts val="500"/>
+              </a:spcBef>
+              <a:buFont typeface="Arial" panose="020B0604020202020204" pitchFamily="34" charset="0"/>
+              <a:buChar char="•"/>
+              <a:defRPr sz="1800" kern="1200">
+                <a:solidFill>
+                  <a:schemeClr val="tx1"/>
+                </a:solidFill>
+                <a:latin typeface="+mn-lt"/>
+                <a:ea typeface="+mn-ea"/>
+                <a:cs typeface="+mn-cs"/>
+              </a:defRPr>
+            </a:lvl8pPr>
+            <a:lvl9pPr marL="3886200" indent="-228600" algn="l" defTabSz="914400" rtl="0" eaLnBrk="1" latinLnBrk="0" hangingPunct="1">
+              <a:lnSpc>
+                <a:spcPct val="90000"/>
+              </a:lnSpc>
+              <a:spcBef>
+                <a:spcPts val="500"/>
+              </a:spcBef>
+              <a:buFont typeface="Arial" panose="020B0604020202020204" pitchFamily="34" charset="0"/>
+              <a:buChar char="•"/>
+              <a:defRPr sz="1800" kern="1200">
+                <a:solidFill>
+                  <a:schemeClr val="tx1"/>
+                </a:solidFill>
+                <a:latin typeface="+mn-lt"/>
+                <a:ea typeface="+mn-ea"/>
+                <a:cs typeface="+mn-cs"/>
+              </a:defRPr>
+            </a:lvl9pPr>
+          </a:lstStyle>
+          <a:p>
+            <a:pPr marL="0" indent="0">
+              <a:buNone/>
+            </a:pPr>
+            <a:r>
+              <a:rPr lang="en-US" sz="3200" dirty="0"/>
+              <a:t>- Used 70:30 split ensuring class representation.</a:t>
+            </a:r>
+          </a:p>
+          <a:p>
+            <a:pPr>
+              <a:buFontTx/>
+              <a:buChar char="-"/>
+            </a:pPr>
+            <a:r>
+              <a:rPr lang="en-US" sz="3200" dirty="0"/>
+              <a:t>Evaluation metric: AUC (Area Under Curve) - We use AUC instead of F1 because : - downtime data is often imbalanced</a:t>
+            </a:r>
+          </a:p>
+          <a:p>
+            <a:pPr>
+              <a:buFontTx/>
+              <a:buChar char="-"/>
+            </a:pPr>
+            <a:r>
+              <a:rPr lang="en-US" sz="3200" b="1" dirty="0">
+                <a:solidFill>
+                  <a:srgbClr val="C00000"/>
+                </a:solidFill>
+              </a:rPr>
+              <a:t>Findings:</a:t>
+            </a:r>
+          </a:p>
+          <a:p>
+            <a:pPr marL="0" indent="0">
+              <a:buNone/>
+            </a:pPr>
+            <a:r>
+              <a:rPr lang="en-US" sz="3200" dirty="0"/>
+              <a:t>- Random Forest achieved highest AUC (best performance)</a:t>
+            </a:r>
+          </a:p>
+          <a:p>
+            <a:pPr marL="0" indent="0">
+              <a:buNone/>
+            </a:pPr>
+            <a:r>
+              <a:rPr lang="en-US" sz="3200" dirty="0"/>
+              <a:t>- Decision Tree showed mild overfitting</a:t>
+            </a:r>
+          </a:p>
+          <a:p>
+            <a:pPr marL="0" indent="0">
+              <a:buNone/>
+            </a:pPr>
+            <a:r>
+              <a:rPr lang="en-US" sz="3200" dirty="0"/>
+              <a:t>- Logistic Regression was stable but less flexible</a:t>
+            </a:r>
+          </a:p>
+          <a:p>
+            <a:pPr marL="0" indent="0">
+              <a:buNone/>
+            </a:pPr>
+            <a:r>
+              <a:rPr lang="en-US" sz="3200" dirty="0"/>
+              <a:t>- Naive Bayes performed lowest due to independence assumptions</a:t>
+            </a:r>
+          </a:p>
+        </p:txBody>
+      </p:sp>
+      <p:sp>
+        <p:nvSpPr>
+          <p:cNvPr id="5" name="Rectangle 4">
+            <a:extLst>
+              <a:ext uri="{FF2B5EF4-FFF2-40B4-BE49-F238E27FC236}">
+                <a16:creationId xmlns:a16="http://schemas.microsoft.com/office/drawing/2014/main" id="{E7878C51-FD5E-8CE0-5298-5228D34465DB}"/>
+              </a:ext>
+            </a:extLst>
+          </p:cNvPr>
+          <p:cNvSpPr/>
+          <p:nvPr/>
+        </p:nvSpPr>
+        <p:spPr>
+          <a:xfrm>
+            <a:off x="0" y="244549"/>
+            <a:ext cx="212651" cy="785690"/>
+          </a:xfrm>
+          <a:prstGeom prst="rect">
+            <a:avLst/>
+          </a:prstGeom>
+          <a:solidFill>
+            <a:srgbClr val="C80000"/>
+          </a:solidFill>
+          <a:ln>
+            <a:solidFill>
+              <a:srgbClr val="C80000"/>
+            </a:solidFill>
+          </a:ln>
+        </p:spPr>
+        <p:style>
+          <a:lnRef idx="2">
+            <a:schemeClr val="accent1">
+              <a:shade val="15000"/>
+            </a:schemeClr>
+          </a:lnRef>
+          <a:fillRef idx="1">
+            <a:schemeClr val="accent1"/>
+          </a:fillRef>
+          <a:effectRef idx="0">
+            <a:schemeClr val="accent1"/>
+          </a:effectRef>
+          <a:fontRef idx="minor">
+            <a:schemeClr val="lt1"/>
+          </a:fontRef>
+        </p:style>
+        <p:txBody>
+          <a:bodyPr rtlCol="0" anchor="ctr"/>
+          <a:lstStyle/>
+          <a:p>
+            <a:pPr marL="0" marR="0" lvl="0" indent="0" algn="ctr" defTabSz="914400" rtl="0" eaLnBrk="1" fontAlgn="auto" latinLnBrk="0" hangingPunct="1">
+              <a:lnSpc>
+                <a:spcPct val="100000"/>
+              </a:lnSpc>
+              <a:spcBef>
+                <a:spcPts val="0"/>
+              </a:spcBef>
+              <a:spcAft>
+                <a:spcPts val="0"/>
+              </a:spcAft>
+              <a:buClrTx/>
+              <a:buSzTx/>
+              <a:buFontTx/>
+              <a:buNone/>
+              <a:tabLst/>
+              <a:defRPr/>
+            </a:pPr>
+            <a:endParaRPr kumimoji="0" lang="en-ZA" sz="1800" b="0" i="0" u="none" strike="noStrike" kern="1200" cap="none" spc="0" normalizeH="0" baseline="0" noProof="0">
+              <a:ln>
+                <a:noFill/>
+              </a:ln>
+              <a:solidFill>
+                <a:srgbClr val="C80000"/>
+              </a:solidFill>
+              <a:effectLst/>
+              <a:uLnTx/>
+              <a:uFillTx/>
+              <a:latin typeface="Calibri" panose="020F0502020204030204"/>
+              <a:ea typeface="+mn-ea"/>
+              <a:cs typeface="+mn-cs"/>
+            </a:endParaRPr>
+          </a:p>
+        </p:txBody>
+      </p:sp>
+      <p:cxnSp>
+        <p:nvCxnSpPr>
+          <p:cNvPr id="6" name="Straight Connector 5">
+            <a:extLst>
+              <a:ext uri="{FF2B5EF4-FFF2-40B4-BE49-F238E27FC236}">
+                <a16:creationId xmlns:a16="http://schemas.microsoft.com/office/drawing/2014/main" id="{57A5BBC0-16CE-8326-181A-F4F58F9585CF}"/>
+              </a:ext>
+            </a:extLst>
+          </p:cNvPr>
+          <p:cNvCxnSpPr>
+            <a:cxnSpLocks/>
+          </p:cNvCxnSpPr>
+          <p:nvPr/>
+        </p:nvCxnSpPr>
+        <p:spPr>
+          <a:xfrm>
+            <a:off x="345839" y="1030239"/>
+            <a:ext cx="11589765" cy="0"/>
+          </a:xfrm>
+          <a:prstGeom prst="line">
+            <a:avLst/>
+          </a:prstGeom>
+          <a:ln w="38100">
+            <a:solidFill>
+              <a:schemeClr val="bg2">
+                <a:lumMod val="75000"/>
+              </a:schemeClr>
+            </a:solidFill>
+          </a:ln>
+        </p:spPr>
+        <p:style>
+          <a:lnRef idx="1">
+            <a:schemeClr val="accent1"/>
+          </a:lnRef>
+          <a:fillRef idx="0">
+            <a:schemeClr val="accent1"/>
+          </a:fillRef>
+          <a:effectRef idx="0">
+            <a:schemeClr val="accent1"/>
+          </a:effectRef>
+          <a:fontRef idx="minor">
+            <a:schemeClr val="tx1"/>
+          </a:fontRef>
+        </p:style>
+      </p:cxnSp>
+      <p:sp>
+        <p:nvSpPr>
+          <p:cNvPr id="8" name="TextBox 7">
+            <a:extLst>
+              <a:ext uri="{FF2B5EF4-FFF2-40B4-BE49-F238E27FC236}">
+                <a16:creationId xmlns:a16="http://schemas.microsoft.com/office/drawing/2014/main" id="{6396D213-E2C4-B2ED-9A6C-1C25A3CE606A}"/>
+              </a:ext>
+            </a:extLst>
+          </p:cNvPr>
+          <p:cNvSpPr txBox="1"/>
+          <p:nvPr/>
+        </p:nvSpPr>
+        <p:spPr>
+          <a:xfrm>
+            <a:off x="5439697" y="1519903"/>
+            <a:ext cx="6100916" cy="369332"/>
+          </a:xfrm>
+          <a:prstGeom prst="rect">
+            <a:avLst/>
+          </a:prstGeom>
+          <a:noFill/>
+        </p:spPr>
+        <p:txBody>
+          <a:bodyPr wrap="square">
+            <a:spAutoFit/>
+          </a:bodyPr>
+          <a:lstStyle/>
+          <a:p>
+            <a:pPr>
+              <a:buNone/>
+            </a:pPr>
+            <a:endParaRPr lang="en-US" b="1" dirty="0"/>
+          </a:p>
+        </p:txBody>
+      </p:sp>
+    </p:spTree>
+    <p:extLst>
+      <p:ext uri="{BB962C8B-B14F-4D97-AF65-F5344CB8AC3E}">
         <p14:creationId xmlns:p14="http://schemas.microsoft.com/office/powerpoint/2010/main" val="2080355228"/>
+      </p:ext>
+    </p:extLst>
+  </p:cSld>
+  <p:clrMapOvr>
+    <a:masterClrMapping/>
+  </p:clrMapOvr>
+</p:sld>
+</file>
+
+<file path=ppt/slides/slide6.xml><?xml version="1.0" encoding="utf-8"?>
+<p:sld xmlns:a="http://schemas.openxmlformats.org/drawingml/2006/main" xmlns:r="http://schemas.openxmlformats.org/officeDocument/2006/relationships" xmlns:p="http://schemas.openxmlformats.org/presentationml/2006/main">
+  <p:cSld>
+    <p:spTree>
+      <p:nvGrpSpPr>
+        <p:cNvPr id="1" name="">
+          <a:extLst>
+            <a:ext uri="{FF2B5EF4-FFF2-40B4-BE49-F238E27FC236}">
+              <a16:creationId xmlns:a16="http://schemas.microsoft.com/office/drawing/2014/main" id="{79F4FF06-D6D5-055B-CCD3-32A0B79A839C}"/>
+            </a:ext>
+          </a:extLst>
+        </p:cNvPr>
+        <p:cNvGrpSpPr/>
+        <p:nvPr/>
+      </p:nvGrpSpPr>
+      <p:grpSpPr>
+        <a:xfrm>
+          <a:off x="0" y="0"/>
+          <a:ext cx="0" cy="0"/>
+          <a:chOff x="0" y="0"/>
+          <a:chExt cx="0" cy="0"/>
+        </a:xfrm>
+      </p:grpSpPr>
+      <p:pic>
+        <p:nvPicPr>
+          <p:cNvPr id="2" name="Picture 1">
+            <a:extLst>
+              <a:ext uri="{FF2B5EF4-FFF2-40B4-BE49-F238E27FC236}">
+                <a16:creationId xmlns:a16="http://schemas.microsoft.com/office/drawing/2014/main" id="{1308EE82-1639-3390-4870-B9D20A4EB522}"/>
+              </a:ext>
+            </a:extLst>
+          </p:cNvPr>
+          <p:cNvPicPr>
+            <a:picLocks noChangeAspect="1"/>
+          </p:cNvPicPr>
+          <p:nvPr/>
+        </p:nvPicPr>
+        <p:blipFill>
+          <a:blip r:embed="rId2" cstate="print">
+            <a:extLst>
+              <a:ext uri="{28A0092B-C50C-407E-A947-70E740481C1C}">
+                <a14:useLocalDpi xmlns:a14="http://schemas.microsoft.com/office/drawing/2010/main" val="0"/>
+              </a:ext>
+            </a:extLst>
+          </a:blip>
+          <a:stretch>
+            <a:fillRect/>
+          </a:stretch>
+        </p:blipFill>
+        <p:spPr>
+          <a:xfrm>
+            <a:off x="9902951" y="170579"/>
+            <a:ext cx="2048257" cy="747614"/>
+          </a:xfrm>
+          <a:prstGeom prst="rect">
+            <a:avLst/>
+          </a:prstGeom>
+        </p:spPr>
+      </p:pic>
+      <p:sp>
+        <p:nvSpPr>
+          <p:cNvPr id="3" name="Content Placeholder 2">
+            <a:extLst>
+              <a:ext uri="{FF2B5EF4-FFF2-40B4-BE49-F238E27FC236}">
+                <a16:creationId xmlns:a16="http://schemas.microsoft.com/office/drawing/2014/main" id="{A28AA4B4-1A31-DDD0-6A28-36192AE9C424}"/>
+              </a:ext>
+            </a:extLst>
+          </p:cNvPr>
+          <p:cNvSpPr txBox="1">
+            <a:spLocks/>
+          </p:cNvSpPr>
+          <p:nvPr/>
+        </p:nvSpPr>
+        <p:spPr>
+          <a:xfrm>
+            <a:off x="403504" y="415048"/>
+            <a:ext cx="9271437" cy="420682"/>
+          </a:xfrm>
+          <a:prstGeom prst="rect">
+            <a:avLst/>
+          </a:prstGeom>
+        </p:spPr>
+        <p:txBody>
+          <a:bodyPr>
+            <a:noAutofit/>
+          </a:bodyPr>
+          <a:lstStyle>
+            <a:lvl1pPr marL="228600" indent="-228600" algn="l" defTabSz="914400" rtl="0" eaLnBrk="1" latinLnBrk="0" hangingPunct="1">
+              <a:lnSpc>
+                <a:spcPct val="90000"/>
+              </a:lnSpc>
+              <a:spcBef>
+                <a:spcPts val="1000"/>
+              </a:spcBef>
+              <a:buFont typeface="Arial" panose="020B0604020202020204" pitchFamily="34" charset="0"/>
+              <a:buChar char="•"/>
+              <a:defRPr sz="2800" kern="1200">
+                <a:solidFill>
+                  <a:schemeClr val="tx1"/>
+                </a:solidFill>
+                <a:latin typeface="+mn-lt"/>
+                <a:ea typeface="+mn-ea"/>
+                <a:cs typeface="+mn-cs"/>
+              </a:defRPr>
+            </a:lvl1pPr>
+            <a:lvl2pPr marL="685800" indent="-228600" algn="l" defTabSz="914400" rtl="0" eaLnBrk="1" latinLnBrk="0" hangingPunct="1">
+              <a:lnSpc>
+                <a:spcPct val="90000"/>
+              </a:lnSpc>
+              <a:spcBef>
+                <a:spcPts val="500"/>
+              </a:spcBef>
+              <a:buFont typeface="Arial" panose="020B0604020202020204" pitchFamily="34" charset="0"/>
+              <a:buChar char="•"/>
+              <a:defRPr sz="2400" kern="1200">
+                <a:solidFill>
+                  <a:schemeClr val="tx1"/>
+                </a:solidFill>
+                <a:latin typeface="+mn-lt"/>
+                <a:ea typeface="+mn-ea"/>
+                <a:cs typeface="+mn-cs"/>
+              </a:defRPr>
+            </a:lvl2pPr>
+            <a:lvl3pPr marL="1143000" indent="-228600" algn="l" defTabSz="914400" rtl="0" eaLnBrk="1" latinLnBrk="0" hangingPunct="1">
+              <a:lnSpc>
+                <a:spcPct val="90000"/>
+              </a:lnSpc>
+              <a:spcBef>
+                <a:spcPts val="500"/>
+              </a:spcBef>
+              <a:buFont typeface="Arial" panose="020B0604020202020204" pitchFamily="34" charset="0"/>
+              <a:buChar char="•"/>
+              <a:defRPr sz="2000" kern="1200">
+                <a:solidFill>
+                  <a:schemeClr val="tx1"/>
+                </a:solidFill>
+                <a:latin typeface="+mn-lt"/>
+                <a:ea typeface="+mn-ea"/>
+                <a:cs typeface="+mn-cs"/>
+              </a:defRPr>
+            </a:lvl3pPr>
+            <a:lvl4pPr marL="1600200" indent="-228600" algn="l" defTabSz="914400" rtl="0" eaLnBrk="1" latinLnBrk="0" hangingPunct="1">
+              <a:lnSpc>
+                <a:spcPct val="90000"/>
+              </a:lnSpc>
+              <a:spcBef>
+                <a:spcPts val="500"/>
+              </a:spcBef>
+              <a:buFont typeface="Arial" panose="020B0604020202020204" pitchFamily="34" charset="0"/>
+              <a:buChar char="•"/>
+              <a:defRPr sz="1800" kern="1200">
+                <a:solidFill>
+                  <a:schemeClr val="tx1"/>
+                </a:solidFill>
+                <a:latin typeface="+mn-lt"/>
+                <a:ea typeface="+mn-ea"/>
+                <a:cs typeface="+mn-cs"/>
+              </a:defRPr>
+            </a:lvl4pPr>
+            <a:lvl5pPr marL="2057400" indent="-228600" algn="l" defTabSz="914400" rtl="0" eaLnBrk="1" latinLnBrk="0" hangingPunct="1">
+              <a:lnSpc>
+                <a:spcPct val="90000"/>
+              </a:lnSpc>
+              <a:spcBef>
+                <a:spcPts val="500"/>
+              </a:spcBef>
+              <a:buFont typeface="Arial" panose="020B0604020202020204" pitchFamily="34" charset="0"/>
+              <a:buChar char="•"/>
+              <a:defRPr sz="1800" kern="1200">
+                <a:solidFill>
+                  <a:schemeClr val="tx1"/>
+                </a:solidFill>
+                <a:latin typeface="+mn-lt"/>
+                <a:ea typeface="+mn-ea"/>
+                <a:cs typeface="+mn-cs"/>
+              </a:defRPr>
+            </a:lvl5pPr>
+            <a:lvl6pPr marL="2514600" indent="-228600" algn="l" defTabSz="914400" rtl="0" eaLnBrk="1" latinLnBrk="0" hangingPunct="1">
+              <a:lnSpc>
+                <a:spcPct val="90000"/>
+              </a:lnSpc>
+              <a:spcBef>
+                <a:spcPts val="500"/>
+              </a:spcBef>
+              <a:buFont typeface="Arial" panose="020B0604020202020204" pitchFamily="34" charset="0"/>
+              <a:buChar char="•"/>
+              <a:defRPr sz="1800" kern="1200">
+                <a:solidFill>
+                  <a:schemeClr val="tx1"/>
+                </a:solidFill>
+                <a:latin typeface="+mn-lt"/>
+                <a:ea typeface="+mn-ea"/>
+                <a:cs typeface="+mn-cs"/>
+              </a:defRPr>
+            </a:lvl6pPr>
+            <a:lvl7pPr marL="2971800" indent="-228600" algn="l" defTabSz="914400" rtl="0" eaLnBrk="1" latinLnBrk="0" hangingPunct="1">
+              <a:lnSpc>
+                <a:spcPct val="90000"/>
+              </a:lnSpc>
+              <a:spcBef>
+                <a:spcPts val="500"/>
+              </a:spcBef>
+              <a:buFont typeface="Arial" panose="020B0604020202020204" pitchFamily="34" charset="0"/>
+              <a:buChar char="•"/>
+              <a:defRPr sz="1800" kern="1200">
+                <a:solidFill>
+                  <a:schemeClr val="tx1"/>
+                </a:solidFill>
+                <a:latin typeface="+mn-lt"/>
+                <a:ea typeface="+mn-ea"/>
+                <a:cs typeface="+mn-cs"/>
+              </a:defRPr>
+            </a:lvl7pPr>
+            <a:lvl8pPr marL="3429000" indent="-228600" algn="l" defTabSz="914400" rtl="0" eaLnBrk="1" latinLnBrk="0" hangingPunct="1">
+              <a:lnSpc>
+                <a:spcPct val="90000"/>
+              </a:lnSpc>
+              <a:spcBef>
+                <a:spcPts val="500"/>
+              </a:spcBef>
+              <a:buFont typeface="Arial" panose="020B0604020202020204" pitchFamily="34" charset="0"/>
+              <a:buChar char="•"/>
+              <a:defRPr sz="1800" kern="1200">
+                <a:solidFill>
+                  <a:schemeClr val="tx1"/>
+                </a:solidFill>
+                <a:latin typeface="+mn-lt"/>
+                <a:ea typeface="+mn-ea"/>
+                <a:cs typeface="+mn-cs"/>
+              </a:defRPr>
+            </a:lvl8pPr>
+            <a:lvl9pPr marL="3886200" indent="-228600" algn="l" defTabSz="914400" rtl="0" eaLnBrk="1" latinLnBrk="0" hangingPunct="1">
+              <a:lnSpc>
+                <a:spcPct val="90000"/>
+              </a:lnSpc>
+              <a:spcBef>
+                <a:spcPts val="500"/>
+              </a:spcBef>
+              <a:buFont typeface="Arial" panose="020B0604020202020204" pitchFamily="34" charset="0"/>
+              <a:buChar char="•"/>
+              <a:defRPr sz="1800" kern="1200">
+                <a:solidFill>
+                  <a:schemeClr val="tx1"/>
+                </a:solidFill>
+                <a:latin typeface="+mn-lt"/>
+                <a:ea typeface="+mn-ea"/>
+                <a:cs typeface="+mn-cs"/>
+              </a:defRPr>
+            </a:lvl9pPr>
+          </a:lstStyle>
+          <a:p>
+            <a:pPr marL="0" indent="0">
+              <a:lnSpc>
+                <a:spcPts val="2900"/>
+              </a:lnSpc>
+              <a:spcBef>
+                <a:spcPts val="0"/>
+              </a:spcBef>
+              <a:spcAft>
+                <a:spcPts val="600"/>
+              </a:spcAft>
+              <a:buNone/>
+            </a:pPr>
+            <a:r>
+              <a:rPr lang="en-US" b="1" dirty="0">
+                <a:solidFill>
+                  <a:srgbClr val="C00000"/>
+                </a:solidFill>
+              </a:rPr>
+              <a:t>Key Drivers &amp; Conclusion</a:t>
+            </a:r>
+          </a:p>
+        </p:txBody>
+      </p:sp>
+      <p:sp>
+        <p:nvSpPr>
+          <p:cNvPr id="4" name="Content Placeholder 2">
+            <a:extLst>
+              <a:ext uri="{FF2B5EF4-FFF2-40B4-BE49-F238E27FC236}">
+                <a16:creationId xmlns:a16="http://schemas.microsoft.com/office/drawing/2014/main" id="{81F2DFB9-892B-ABE5-625D-8F1D5C367469}"/>
+              </a:ext>
+            </a:extLst>
+          </p:cNvPr>
+          <p:cNvSpPr txBox="1">
+            <a:spLocks/>
+          </p:cNvSpPr>
+          <p:nvPr/>
+        </p:nvSpPr>
+        <p:spPr>
+          <a:xfrm>
+            <a:off x="228142" y="1142286"/>
+            <a:ext cx="11707462" cy="5622029"/>
+          </a:xfrm>
+          <a:prstGeom prst="rect">
+            <a:avLst/>
+          </a:prstGeom>
+        </p:spPr>
+        <p:txBody>
+          <a:bodyPr>
+            <a:noAutofit/>
+          </a:bodyPr>
+          <a:lstStyle>
+            <a:lvl1pPr marL="228600" indent="-228600" algn="l" defTabSz="914400" rtl="0" eaLnBrk="1" latinLnBrk="0" hangingPunct="1">
+              <a:lnSpc>
+                <a:spcPct val="90000"/>
+              </a:lnSpc>
+              <a:spcBef>
+                <a:spcPts val="1000"/>
+              </a:spcBef>
+              <a:buFont typeface="Arial" panose="020B0604020202020204" pitchFamily="34" charset="0"/>
+              <a:buChar char="•"/>
+              <a:defRPr sz="2800" kern="1200">
+                <a:solidFill>
+                  <a:schemeClr val="tx1"/>
+                </a:solidFill>
+                <a:latin typeface="+mn-lt"/>
+                <a:ea typeface="+mn-ea"/>
+                <a:cs typeface="+mn-cs"/>
+              </a:defRPr>
+            </a:lvl1pPr>
+            <a:lvl2pPr marL="685800" indent="-228600" algn="l" defTabSz="914400" rtl="0" eaLnBrk="1" latinLnBrk="0" hangingPunct="1">
+              <a:lnSpc>
+                <a:spcPct val="90000"/>
+              </a:lnSpc>
+              <a:spcBef>
+                <a:spcPts val="500"/>
+              </a:spcBef>
+              <a:buFont typeface="Arial" panose="020B0604020202020204" pitchFamily="34" charset="0"/>
+              <a:buChar char="•"/>
+              <a:defRPr sz="2400" kern="1200">
+                <a:solidFill>
+                  <a:schemeClr val="tx1"/>
+                </a:solidFill>
+                <a:latin typeface="+mn-lt"/>
+                <a:ea typeface="+mn-ea"/>
+                <a:cs typeface="+mn-cs"/>
+              </a:defRPr>
+            </a:lvl2pPr>
+            <a:lvl3pPr marL="1143000" indent="-228600" algn="l" defTabSz="914400" rtl="0" eaLnBrk="1" latinLnBrk="0" hangingPunct="1">
+              <a:lnSpc>
+                <a:spcPct val="90000"/>
+              </a:lnSpc>
+              <a:spcBef>
+                <a:spcPts val="500"/>
+              </a:spcBef>
+              <a:buFont typeface="Arial" panose="020B0604020202020204" pitchFamily="34" charset="0"/>
+              <a:buChar char="•"/>
+              <a:defRPr sz="2000" kern="1200">
+                <a:solidFill>
+                  <a:schemeClr val="tx1"/>
+                </a:solidFill>
+                <a:latin typeface="+mn-lt"/>
+                <a:ea typeface="+mn-ea"/>
+                <a:cs typeface="+mn-cs"/>
+              </a:defRPr>
+            </a:lvl3pPr>
+            <a:lvl4pPr marL="1600200" indent="-228600" algn="l" defTabSz="914400" rtl="0" eaLnBrk="1" latinLnBrk="0" hangingPunct="1">
+              <a:lnSpc>
+                <a:spcPct val="90000"/>
+              </a:lnSpc>
+              <a:spcBef>
+                <a:spcPts val="500"/>
+              </a:spcBef>
+              <a:buFont typeface="Arial" panose="020B0604020202020204" pitchFamily="34" charset="0"/>
+              <a:buChar char="•"/>
+              <a:defRPr sz="1800" kern="1200">
+                <a:solidFill>
+                  <a:schemeClr val="tx1"/>
+                </a:solidFill>
+                <a:latin typeface="+mn-lt"/>
+                <a:ea typeface="+mn-ea"/>
+                <a:cs typeface="+mn-cs"/>
+              </a:defRPr>
+            </a:lvl4pPr>
+            <a:lvl5pPr marL="2057400" indent="-228600" algn="l" defTabSz="914400" rtl="0" eaLnBrk="1" latinLnBrk="0" hangingPunct="1">
+              <a:lnSpc>
+                <a:spcPct val="90000"/>
+              </a:lnSpc>
+              <a:spcBef>
+                <a:spcPts val="500"/>
+              </a:spcBef>
+              <a:buFont typeface="Arial" panose="020B0604020202020204" pitchFamily="34" charset="0"/>
+              <a:buChar char="•"/>
+              <a:defRPr sz="1800" kern="1200">
+                <a:solidFill>
+                  <a:schemeClr val="tx1"/>
+                </a:solidFill>
+                <a:latin typeface="+mn-lt"/>
+                <a:ea typeface="+mn-ea"/>
+                <a:cs typeface="+mn-cs"/>
+              </a:defRPr>
+            </a:lvl5pPr>
+            <a:lvl6pPr marL="2514600" indent="-228600" algn="l" defTabSz="914400" rtl="0" eaLnBrk="1" latinLnBrk="0" hangingPunct="1">
+              <a:lnSpc>
+                <a:spcPct val="90000"/>
+              </a:lnSpc>
+              <a:spcBef>
+                <a:spcPts val="500"/>
+              </a:spcBef>
+              <a:buFont typeface="Arial" panose="020B0604020202020204" pitchFamily="34" charset="0"/>
+              <a:buChar char="•"/>
+              <a:defRPr sz="1800" kern="1200">
+                <a:solidFill>
+                  <a:schemeClr val="tx1"/>
+                </a:solidFill>
+                <a:latin typeface="+mn-lt"/>
+                <a:ea typeface="+mn-ea"/>
+                <a:cs typeface="+mn-cs"/>
+              </a:defRPr>
+            </a:lvl6pPr>
+            <a:lvl7pPr marL="2971800" indent="-228600" algn="l" defTabSz="914400" rtl="0" eaLnBrk="1" latinLnBrk="0" hangingPunct="1">
+              <a:lnSpc>
+                <a:spcPct val="90000"/>
+              </a:lnSpc>
+              <a:spcBef>
+                <a:spcPts val="500"/>
+              </a:spcBef>
+              <a:buFont typeface="Arial" panose="020B0604020202020204" pitchFamily="34" charset="0"/>
+              <a:buChar char="•"/>
+              <a:defRPr sz="1800" kern="1200">
+                <a:solidFill>
+                  <a:schemeClr val="tx1"/>
+                </a:solidFill>
+                <a:latin typeface="+mn-lt"/>
+                <a:ea typeface="+mn-ea"/>
+                <a:cs typeface="+mn-cs"/>
+              </a:defRPr>
+            </a:lvl7pPr>
+            <a:lvl8pPr marL="3429000" indent="-228600" algn="l" defTabSz="914400" rtl="0" eaLnBrk="1" latinLnBrk="0" hangingPunct="1">
+              <a:lnSpc>
+                <a:spcPct val="90000"/>
+              </a:lnSpc>
+              <a:spcBef>
+                <a:spcPts val="500"/>
+              </a:spcBef>
+              <a:buFont typeface="Arial" panose="020B0604020202020204" pitchFamily="34" charset="0"/>
+              <a:buChar char="•"/>
+              <a:defRPr sz="1800" kern="1200">
+                <a:solidFill>
+                  <a:schemeClr val="tx1"/>
+                </a:solidFill>
+                <a:latin typeface="+mn-lt"/>
+                <a:ea typeface="+mn-ea"/>
+                <a:cs typeface="+mn-cs"/>
+              </a:defRPr>
+            </a:lvl8pPr>
+            <a:lvl9pPr marL="3886200" indent="-228600" algn="l" defTabSz="914400" rtl="0" eaLnBrk="1" latinLnBrk="0" hangingPunct="1">
+              <a:lnSpc>
+                <a:spcPct val="90000"/>
+              </a:lnSpc>
+              <a:spcBef>
+                <a:spcPts val="500"/>
+              </a:spcBef>
+              <a:buFont typeface="Arial" panose="020B0604020202020204" pitchFamily="34" charset="0"/>
+              <a:buChar char="•"/>
+              <a:defRPr sz="1800" kern="1200">
+                <a:solidFill>
+                  <a:schemeClr val="tx1"/>
+                </a:solidFill>
+                <a:latin typeface="+mn-lt"/>
+                <a:ea typeface="+mn-ea"/>
+                <a:cs typeface="+mn-cs"/>
+              </a:defRPr>
+            </a:lvl9pPr>
+          </a:lstStyle>
+          <a:p>
+            <a:r>
+              <a:rPr lang="en-US" dirty="0"/>
+              <a:t>Top predictive features (Random Forest):</a:t>
+            </a:r>
+          </a:p>
+          <a:p>
+            <a:pPr marL="0" indent="0">
+              <a:buNone/>
+            </a:pPr>
+            <a:r>
+              <a:rPr lang="en-US" dirty="0"/>
+              <a:t>- Downtime Duration</a:t>
+            </a:r>
+          </a:p>
+          <a:p>
+            <a:pPr marL="0" indent="0">
+              <a:buNone/>
+            </a:pPr>
+            <a:r>
+              <a:rPr lang="en-US" dirty="0"/>
+              <a:t>- Fault Duration</a:t>
+            </a:r>
+          </a:p>
+          <a:p>
+            <a:pPr marL="0" indent="0">
+              <a:buNone/>
+            </a:pPr>
+            <a:r>
+              <a:rPr lang="en-US" dirty="0"/>
+              <a:t>- Emergency Flag</a:t>
+            </a:r>
+          </a:p>
+          <a:p>
+            <a:pPr marL="0" indent="0">
+              <a:buNone/>
+            </a:pPr>
+            <a:r>
+              <a:rPr lang="en-US" dirty="0"/>
+              <a:t>- Downtime Type</a:t>
+            </a:r>
+          </a:p>
+          <a:p>
+            <a:pPr marL="0" indent="0">
+              <a:buNone/>
+            </a:pPr>
+            <a:r>
+              <a:rPr lang="en-US" dirty="0"/>
+              <a:t>- Hour of occurrence</a:t>
+            </a:r>
+          </a:p>
+          <a:p>
+            <a:r>
+              <a:rPr lang="en-US" b="1" dirty="0">
+                <a:solidFill>
+                  <a:srgbClr val="C00000"/>
+                </a:solidFill>
+              </a:rPr>
+              <a:t>Conclusion:</a:t>
+            </a:r>
+          </a:p>
+          <a:p>
+            <a:pPr>
+              <a:buFont typeface="Wingdings" panose="05000000000000000000" pitchFamily="2" charset="2"/>
+              <a:buChar char="ü"/>
+            </a:pPr>
+            <a:r>
+              <a:rPr lang="en-US" dirty="0"/>
+              <a:t>Random Forest provided the best balance of accuracy and </a:t>
+            </a:r>
+            <a:r>
+              <a:rPr lang="en-US" dirty="0" err="1"/>
+              <a:t>generalisation</a:t>
+            </a:r>
+            <a:r>
+              <a:rPr lang="en-US" dirty="0"/>
+              <a:t>. Feature engineering significantly improved predictive power for maintenance classification.</a:t>
+            </a:r>
+          </a:p>
+          <a:p>
+            <a:pPr>
+              <a:buFont typeface="Wingdings" panose="05000000000000000000" pitchFamily="2" charset="2"/>
+              <a:buChar char="ü"/>
+            </a:pPr>
+            <a:r>
+              <a:rPr lang="en-US" dirty="0"/>
+              <a:t>Time + severity + operational context drive maintenance needs &amp; save companies money</a:t>
+            </a:r>
+          </a:p>
+          <a:p>
+            <a:pPr>
+              <a:buFont typeface="Wingdings" panose="05000000000000000000" pitchFamily="2" charset="2"/>
+              <a:buChar char="ü"/>
+            </a:pPr>
+            <a:endParaRPr lang="en-US" dirty="0"/>
+          </a:p>
+        </p:txBody>
+      </p:sp>
+      <p:sp>
+        <p:nvSpPr>
+          <p:cNvPr id="5" name="Rectangle 4">
+            <a:extLst>
+              <a:ext uri="{FF2B5EF4-FFF2-40B4-BE49-F238E27FC236}">
+                <a16:creationId xmlns:a16="http://schemas.microsoft.com/office/drawing/2014/main" id="{95191B54-F956-9613-A740-4E2723A1791A}"/>
+              </a:ext>
+            </a:extLst>
+          </p:cNvPr>
+          <p:cNvSpPr/>
+          <p:nvPr/>
+        </p:nvSpPr>
+        <p:spPr>
+          <a:xfrm>
+            <a:off x="0" y="244549"/>
+            <a:ext cx="212651" cy="785690"/>
+          </a:xfrm>
+          <a:prstGeom prst="rect">
+            <a:avLst/>
+          </a:prstGeom>
+          <a:solidFill>
+            <a:srgbClr val="C80000"/>
+          </a:solidFill>
+          <a:ln>
+            <a:solidFill>
+              <a:srgbClr val="C80000"/>
+            </a:solidFill>
+          </a:ln>
+        </p:spPr>
+        <p:style>
+          <a:lnRef idx="2">
+            <a:schemeClr val="accent1">
+              <a:shade val="15000"/>
+            </a:schemeClr>
+          </a:lnRef>
+          <a:fillRef idx="1">
+            <a:schemeClr val="accent1"/>
+          </a:fillRef>
+          <a:effectRef idx="0">
+            <a:schemeClr val="accent1"/>
+          </a:effectRef>
+          <a:fontRef idx="minor">
+            <a:schemeClr val="lt1"/>
+          </a:fontRef>
+        </p:style>
+        <p:txBody>
+          <a:bodyPr rtlCol="0" anchor="ctr"/>
+          <a:lstStyle/>
+          <a:p>
+            <a:pPr marL="0" marR="0" lvl="0" indent="0" algn="ctr" defTabSz="914400" rtl="0" eaLnBrk="1" fontAlgn="auto" latinLnBrk="0" hangingPunct="1">
+              <a:lnSpc>
+                <a:spcPct val="100000"/>
+              </a:lnSpc>
+              <a:spcBef>
+                <a:spcPts val="0"/>
+              </a:spcBef>
+              <a:spcAft>
+                <a:spcPts val="0"/>
+              </a:spcAft>
+              <a:buClrTx/>
+              <a:buSzTx/>
+              <a:buFontTx/>
+              <a:buNone/>
+              <a:tabLst/>
+              <a:defRPr/>
+            </a:pPr>
+            <a:endParaRPr kumimoji="0" lang="en-ZA" sz="1800" b="0" i="0" u="none" strike="noStrike" kern="1200" cap="none" spc="0" normalizeH="0" baseline="0" noProof="0">
+              <a:ln>
+                <a:noFill/>
+              </a:ln>
+              <a:solidFill>
+                <a:srgbClr val="C80000"/>
+              </a:solidFill>
+              <a:effectLst/>
+              <a:uLnTx/>
+              <a:uFillTx/>
+              <a:latin typeface="Calibri" panose="020F0502020204030204"/>
+              <a:ea typeface="+mn-ea"/>
+              <a:cs typeface="+mn-cs"/>
+            </a:endParaRPr>
+          </a:p>
+        </p:txBody>
+      </p:sp>
+      <p:cxnSp>
+        <p:nvCxnSpPr>
+          <p:cNvPr id="6" name="Straight Connector 5">
+            <a:extLst>
+              <a:ext uri="{FF2B5EF4-FFF2-40B4-BE49-F238E27FC236}">
+                <a16:creationId xmlns:a16="http://schemas.microsoft.com/office/drawing/2014/main" id="{F2382E26-0177-2902-CD58-C33D4FE2B692}"/>
+              </a:ext>
+            </a:extLst>
+          </p:cNvPr>
+          <p:cNvCxnSpPr>
+            <a:cxnSpLocks/>
+          </p:cNvCxnSpPr>
+          <p:nvPr/>
+        </p:nvCxnSpPr>
+        <p:spPr>
+          <a:xfrm>
+            <a:off x="345839" y="1030239"/>
+            <a:ext cx="11589765" cy="0"/>
+          </a:xfrm>
+          <a:prstGeom prst="line">
+            <a:avLst/>
+          </a:prstGeom>
+          <a:ln w="38100">
+            <a:solidFill>
+              <a:schemeClr val="bg2">
+                <a:lumMod val="75000"/>
+              </a:schemeClr>
+            </a:solidFill>
+          </a:ln>
+        </p:spPr>
+        <p:style>
+          <a:lnRef idx="1">
+            <a:schemeClr val="accent1"/>
+          </a:lnRef>
+          <a:fillRef idx="0">
+            <a:schemeClr val="accent1"/>
+          </a:fillRef>
+          <a:effectRef idx="0">
+            <a:schemeClr val="accent1"/>
+          </a:effectRef>
+          <a:fontRef idx="minor">
+            <a:schemeClr val="tx1"/>
+          </a:fontRef>
+        </p:style>
+      </p:cxnSp>
+      <p:sp>
+        <p:nvSpPr>
+          <p:cNvPr id="8" name="TextBox 7">
+            <a:extLst>
+              <a:ext uri="{FF2B5EF4-FFF2-40B4-BE49-F238E27FC236}">
+                <a16:creationId xmlns:a16="http://schemas.microsoft.com/office/drawing/2014/main" id="{B9CC4A1B-8A15-5E83-1FF5-91EC3DAA88DC}"/>
+              </a:ext>
+            </a:extLst>
+          </p:cNvPr>
+          <p:cNvSpPr txBox="1"/>
+          <p:nvPr/>
+        </p:nvSpPr>
+        <p:spPr>
+          <a:xfrm>
+            <a:off x="5439697" y="1519903"/>
+            <a:ext cx="6100916" cy="369332"/>
+          </a:xfrm>
+          <a:prstGeom prst="rect">
+            <a:avLst/>
+          </a:prstGeom>
+          <a:noFill/>
+        </p:spPr>
+        <p:txBody>
+          <a:bodyPr wrap="square">
+            <a:spAutoFit/>
+          </a:bodyPr>
+          <a:lstStyle/>
+          <a:p>
+            <a:pPr>
+              <a:buNone/>
+            </a:pPr>
+            <a:endParaRPr lang="en-US" b="1" dirty="0"/>
+          </a:p>
+        </p:txBody>
+      </p:sp>
+    </p:spTree>
+    <p:extLst>
+      <p:ext uri="{BB962C8B-B14F-4D97-AF65-F5344CB8AC3E}">
+        <p14:creationId xmlns:p14="http://schemas.microsoft.com/office/powerpoint/2010/main" val="585638465"/>
       </p:ext>
     </p:extLst>
   </p:cSld>

</xml_diff>

<commit_message>
Updated the slides, and the decision tree and P1 value
</commit_message>
<xml_diff>
--- a/Binary Classification 606.pptx
+++ b/Binary Classification 606.pptx
@@ -202,7 +202,7 @@
           <a:p>
             <a:fld id="{F94E02D4-7CEE-4426-B842-C52CC7EAF1AF}" type="datetimeFigureOut">
               <a:rPr lang="en-ZA" smtClean="0"/>
-              <a:t>2026/04/28</a:t>
+              <a:t>2026/05/14</a:t>
             </a:fld>
             <a:endParaRPr lang="en-ZA"/>
           </a:p>
@@ -470,6 +470,292 @@
 </p:notesMaster>
 </file>
 
+<file path=ppt/notesSlides/notesSlide1.xml><?xml version="1.0" encoding="utf-8"?>
+<p:notes xmlns:a="http://schemas.openxmlformats.org/drawingml/2006/main" xmlns:r="http://schemas.openxmlformats.org/officeDocument/2006/relationships" xmlns:p="http://schemas.openxmlformats.org/presentationml/2006/main">
+  <p:cSld>
+    <p:spTree>
+      <p:nvGrpSpPr>
+        <p:cNvPr id="1" name=""/>
+        <p:cNvGrpSpPr/>
+        <p:nvPr/>
+      </p:nvGrpSpPr>
+      <p:grpSpPr>
+        <a:xfrm>
+          <a:off x="0" y="0"/>
+          <a:ext cx="0" cy="0"/>
+          <a:chOff x="0" y="0"/>
+          <a:chExt cx="0" cy="0"/>
+        </a:xfrm>
+      </p:grpSpPr>
+      <p:sp>
+        <p:nvSpPr>
+          <p:cNvPr id="2" name="Slide Image Placeholder 1"/>
+          <p:cNvSpPr>
+            <a:spLocks noGrp="1" noRot="1" noChangeAspect="1"/>
+          </p:cNvSpPr>
+          <p:nvPr>
+            <p:ph type="sldImg"/>
+          </p:nvPr>
+        </p:nvSpPr>
+        <p:spPr/>
+      </p:sp>
+      <p:sp>
+        <p:nvSpPr>
+          <p:cNvPr id="3" name="Notes Placeholder 2"/>
+          <p:cNvSpPr>
+            <a:spLocks noGrp="1"/>
+          </p:cNvSpPr>
+          <p:nvPr>
+            <p:ph type="body" idx="1"/>
+          </p:nvPr>
+        </p:nvSpPr>
+        <p:spPr/>
+        <p:txBody>
+          <a:bodyPr/>
+          <a:lstStyle/>
+          <a:p>
+            <a:pPr fontAlgn="t"/>
+            <a:r>
+              <a:rPr lang="en-US" sz="1200" b="0" i="0" kern="1200" dirty="0">
+                <a:solidFill>
+                  <a:schemeClr val="tx1"/>
+                </a:solidFill>
+                <a:effectLst/>
+                <a:latin typeface="+mn-lt"/>
+                <a:ea typeface="+mn-ea"/>
+                <a:cs typeface="+mn-cs"/>
+              </a:rPr>
+              <a:t>Based on AUC evaluated on a held‑out test set, the </a:t>
+            </a:r>
+          </a:p>
+          <a:p>
+            <a:pPr marL="171450" indent="-171450" fontAlgn="t">
+              <a:buFont typeface="Wingdings" panose="05000000000000000000" pitchFamily="2" charset="2"/>
+              <a:buChar char="ü"/>
+            </a:pPr>
+            <a:r>
+              <a:rPr lang="en-US" sz="1200" b="1" i="0" kern="1200" dirty="0">
+                <a:solidFill>
+                  <a:schemeClr val="tx1"/>
+                </a:solidFill>
+                <a:effectLst/>
+                <a:latin typeface="+mn-lt"/>
+                <a:ea typeface="+mn-ea"/>
+                <a:cs typeface="+mn-cs"/>
+              </a:rPr>
+              <a:t>Decision Tree</a:t>
+            </a:r>
+            <a:r>
+              <a:rPr lang="en-US" sz="1200" b="0" i="0" kern="1200" dirty="0">
+                <a:solidFill>
+                  <a:schemeClr val="tx1"/>
+                </a:solidFill>
+                <a:effectLst/>
+                <a:latin typeface="+mn-lt"/>
+                <a:ea typeface="+mn-ea"/>
+                <a:cs typeface="+mn-cs"/>
+              </a:rPr>
+              <a:t> achieved the best predictive performance (AUC ≈ 0.7322), indicating the strongest overall discriminative ability. </a:t>
+            </a:r>
+          </a:p>
+          <a:p>
+            <a:pPr marL="171450" indent="-171450" fontAlgn="t">
+              <a:buFont typeface="Wingdings" panose="05000000000000000000" pitchFamily="2" charset="2"/>
+              <a:buChar char="ü"/>
+            </a:pPr>
+            <a:r>
+              <a:rPr lang="en-US" sz="1200" b="1" i="0" kern="1200" dirty="0">
+                <a:solidFill>
+                  <a:schemeClr val="tx1"/>
+                </a:solidFill>
+                <a:effectLst/>
+                <a:latin typeface="+mn-lt"/>
+                <a:ea typeface="+mn-ea"/>
+                <a:cs typeface="+mn-cs"/>
+              </a:rPr>
+              <a:t>Logistic Regression</a:t>
+            </a:r>
+            <a:r>
+              <a:rPr lang="en-US" sz="1200" b="0" i="0" kern="1200" dirty="0">
+                <a:solidFill>
+                  <a:schemeClr val="tx1"/>
+                </a:solidFill>
+                <a:effectLst/>
+                <a:latin typeface="+mn-lt"/>
+                <a:ea typeface="+mn-ea"/>
+                <a:cs typeface="+mn-cs"/>
+              </a:rPr>
+              <a:t> showed moderate performance, constrained by its linear modelling assumptions. In contrast, </a:t>
+            </a:r>
+          </a:p>
+          <a:p>
+            <a:pPr marL="171450" indent="-171450" fontAlgn="t">
+              <a:buFont typeface="Wingdings" panose="05000000000000000000" pitchFamily="2" charset="2"/>
+              <a:buChar char="ü"/>
+            </a:pPr>
+            <a:r>
+              <a:rPr lang="en-US" sz="1200" b="1" i="0" kern="1200" dirty="0">
+                <a:solidFill>
+                  <a:schemeClr val="tx1"/>
+                </a:solidFill>
+                <a:effectLst/>
+                <a:latin typeface="+mn-lt"/>
+                <a:ea typeface="+mn-ea"/>
+                <a:cs typeface="+mn-cs"/>
+              </a:rPr>
+              <a:t>Naïve Bayes </a:t>
+            </a:r>
+            <a:r>
+              <a:rPr lang="en-US" sz="1200" b="0" i="0" kern="1200" dirty="0">
+                <a:solidFill>
+                  <a:schemeClr val="tx1"/>
+                </a:solidFill>
+                <a:effectLst/>
+                <a:latin typeface="+mn-lt"/>
+                <a:ea typeface="+mn-ea"/>
+                <a:cs typeface="+mn-cs"/>
+              </a:rPr>
+              <a:t>exhibited weak </a:t>
+            </a:r>
+            <a:r>
+              <a:rPr lang="en-US" sz="1200" b="0" i="0" kern="1200" dirty="0" err="1">
+                <a:solidFill>
+                  <a:schemeClr val="tx1"/>
+                </a:solidFill>
+                <a:effectLst/>
+                <a:latin typeface="+mn-lt"/>
+                <a:ea typeface="+mn-ea"/>
+                <a:cs typeface="+mn-cs"/>
+              </a:rPr>
+              <a:t>generalisation</a:t>
+            </a:r>
+            <a:r>
+              <a:rPr lang="en-US" sz="1200" b="0" i="0" kern="1200" dirty="0">
+                <a:solidFill>
+                  <a:schemeClr val="tx1"/>
+                </a:solidFill>
+                <a:effectLst/>
+                <a:latin typeface="+mn-lt"/>
+                <a:ea typeface="+mn-ea"/>
+                <a:cs typeface="+mn-cs"/>
+              </a:rPr>
+              <a:t> after data cleaning and leakage removal, suggesting that its conditional independence assumption was not well suited to the final feature set.</a:t>
+            </a:r>
+          </a:p>
+          <a:p>
+            <a:pPr marL="171450" indent="-171450" fontAlgn="t">
+              <a:buFont typeface="Wingdings" panose="05000000000000000000" pitchFamily="2" charset="2"/>
+              <a:buChar char="ü"/>
+            </a:pPr>
+            <a:endParaRPr lang="en-US" sz="1200" b="0" i="0" kern="1200" dirty="0">
+              <a:solidFill>
+                <a:schemeClr val="tx1"/>
+              </a:solidFill>
+              <a:effectLst/>
+              <a:latin typeface="+mn-lt"/>
+              <a:ea typeface="+mn-ea"/>
+              <a:cs typeface="+mn-cs"/>
+            </a:endParaRPr>
+          </a:p>
+          <a:p>
+            <a:pPr marL="0" indent="0" fontAlgn="t">
+              <a:buFont typeface="Wingdings" panose="05000000000000000000" pitchFamily="2" charset="2"/>
+              <a:buNone/>
+            </a:pPr>
+            <a:r>
+              <a:rPr lang="en-US" sz="1200" b="0" i="0" kern="1200" dirty="0">
+                <a:solidFill>
+                  <a:schemeClr val="tx1"/>
+                </a:solidFill>
+                <a:effectLst/>
+                <a:latin typeface="+mn-lt"/>
+                <a:ea typeface="+mn-ea"/>
+                <a:cs typeface="+mn-cs"/>
+              </a:rPr>
+              <a:t> Consequently, feature importance and key drivers of maintenance were interpreted primarily using the Decision Tree and supported by Logistic Regression. The results further demonstrate that feature engineering substantially improved predictive power, with downtime severity, time‑based patterns, and operational context emerging as the primary drivers of maintenance requirements.</a:t>
+            </a:r>
+          </a:p>
+          <a:p>
+            <a:pPr fontAlgn="t"/>
+            <a:endParaRPr lang="en-US" sz="1200" b="0" i="0" kern="1200" dirty="0">
+              <a:solidFill>
+                <a:schemeClr val="tx1"/>
+              </a:solidFill>
+              <a:effectLst/>
+              <a:latin typeface="+mn-lt"/>
+              <a:ea typeface="+mn-ea"/>
+              <a:cs typeface="+mn-cs"/>
+            </a:endParaRPr>
+          </a:p>
+          <a:p>
+            <a:pPr marL="0" marR="0" lvl="0" indent="0" algn="l" defTabSz="914400" rtl="0" eaLnBrk="1" fontAlgn="auto" latinLnBrk="0" hangingPunct="1">
+              <a:lnSpc>
+                <a:spcPct val="100000"/>
+              </a:lnSpc>
+              <a:spcBef>
+                <a:spcPts val="0"/>
+              </a:spcBef>
+              <a:spcAft>
+                <a:spcPts val="0"/>
+              </a:spcAft>
+              <a:buClrTx/>
+              <a:buSzTx/>
+              <a:buFontTx/>
+              <a:buNone/>
+              <a:tabLst/>
+              <a:defRPr/>
+            </a:pPr>
+            <a:endParaRPr lang="en-US" sz="1400" b="0" i="0" kern="1200" dirty="0">
+              <a:solidFill>
+                <a:schemeClr val="tx1"/>
+              </a:solidFill>
+              <a:effectLst/>
+              <a:latin typeface="+mn-lt"/>
+              <a:ea typeface="+mn-ea"/>
+              <a:cs typeface="+mn-cs"/>
+            </a:endParaRPr>
+          </a:p>
+          <a:p>
+            <a:endParaRPr lang="en-US" dirty="0"/>
+          </a:p>
+        </p:txBody>
+      </p:sp>
+      <p:sp>
+        <p:nvSpPr>
+          <p:cNvPr id="4" name="Slide Number Placeholder 3"/>
+          <p:cNvSpPr>
+            <a:spLocks noGrp="1"/>
+          </p:cNvSpPr>
+          <p:nvPr>
+            <p:ph type="sldNum" sz="quarter" idx="5"/>
+          </p:nvPr>
+        </p:nvSpPr>
+        <p:spPr/>
+        <p:txBody>
+          <a:bodyPr/>
+          <a:lstStyle/>
+          <a:p>
+            <a:fld id="{C6A4A676-2660-4BB4-BF48-DD096EA23FE3}" type="slidenum">
+              <a:rPr lang="en-ZA" smtClean="0"/>
+              <a:t>6</a:t>
+            </a:fld>
+            <a:endParaRPr lang="en-ZA"/>
+          </a:p>
+        </p:txBody>
+      </p:sp>
+    </p:spTree>
+    <p:extLst>
+      <p:ext uri="{BB962C8B-B14F-4D97-AF65-F5344CB8AC3E}">
+        <p14:creationId xmlns:p14="http://schemas.microsoft.com/office/powerpoint/2010/main" val="568294065"/>
+      </p:ext>
+    </p:extLst>
+  </p:cSld>
+  <p:clrMapOvr>
+    <a:masterClrMapping/>
+  </p:clrMapOvr>
+</p:notes>
+</file>
+
 <file path=ppt/slideLayouts/slideLayout1.xml><?xml version="1.0" encoding="utf-8"?>
 <p:sldLayout xmlns:a="http://schemas.openxmlformats.org/drawingml/2006/main" xmlns:r="http://schemas.openxmlformats.org/officeDocument/2006/relationships" xmlns:p="http://schemas.openxmlformats.org/presentationml/2006/main" type="title" preserve="1">
   <p:cSld name="Title Slide">
@@ -619,7 +905,7 @@
           <a:p>
             <a:fld id="{D3997BC2-908B-4AE2-B66B-0BE82B2F56FB}" type="datetimeFigureOut">
               <a:rPr lang="en-ZA" smtClean="0"/>
-              <a:t>2026/04/28</a:t>
+              <a:t>2026/05/14</a:t>
             </a:fld>
             <a:endParaRPr lang="en-ZA"/>
           </a:p>
@@ -819,7 +1105,7 @@
           <a:p>
             <a:fld id="{D3997BC2-908B-4AE2-B66B-0BE82B2F56FB}" type="datetimeFigureOut">
               <a:rPr lang="en-ZA" smtClean="0"/>
-              <a:t>2026/04/28</a:t>
+              <a:t>2026/05/14</a:t>
             </a:fld>
             <a:endParaRPr lang="en-ZA"/>
           </a:p>
@@ -1029,7 +1315,7 @@
           <a:p>
             <a:fld id="{D3997BC2-908B-4AE2-B66B-0BE82B2F56FB}" type="datetimeFigureOut">
               <a:rPr lang="en-ZA" smtClean="0"/>
-              <a:t>2026/04/28</a:t>
+              <a:t>2026/05/14</a:t>
             </a:fld>
             <a:endParaRPr lang="en-ZA"/>
           </a:p>
@@ -1229,7 +1515,7 @@
           <a:p>
             <a:fld id="{D3997BC2-908B-4AE2-B66B-0BE82B2F56FB}" type="datetimeFigureOut">
               <a:rPr lang="en-ZA" smtClean="0"/>
-              <a:t>2026/04/28</a:t>
+              <a:t>2026/05/14</a:t>
             </a:fld>
             <a:endParaRPr lang="en-ZA"/>
           </a:p>
@@ -1505,7 +1791,7 @@
           <a:p>
             <a:fld id="{D3997BC2-908B-4AE2-B66B-0BE82B2F56FB}" type="datetimeFigureOut">
               <a:rPr lang="en-ZA" smtClean="0"/>
-              <a:t>2026/04/28</a:t>
+              <a:t>2026/05/14</a:t>
             </a:fld>
             <a:endParaRPr lang="en-ZA"/>
           </a:p>
@@ -1773,7 +2059,7 @@
           <a:p>
             <a:fld id="{D3997BC2-908B-4AE2-B66B-0BE82B2F56FB}" type="datetimeFigureOut">
               <a:rPr lang="en-ZA" smtClean="0"/>
-              <a:t>2026/04/28</a:t>
+              <a:t>2026/05/14</a:t>
             </a:fld>
             <a:endParaRPr lang="en-ZA"/>
           </a:p>
@@ -2188,7 +2474,7 @@
           <a:p>
             <a:fld id="{D3997BC2-908B-4AE2-B66B-0BE82B2F56FB}" type="datetimeFigureOut">
               <a:rPr lang="en-ZA" smtClean="0"/>
-              <a:t>2026/04/28</a:t>
+              <a:t>2026/05/14</a:t>
             </a:fld>
             <a:endParaRPr lang="en-ZA"/>
           </a:p>
@@ -2330,7 +2616,7 @@
           <a:p>
             <a:fld id="{D3997BC2-908B-4AE2-B66B-0BE82B2F56FB}" type="datetimeFigureOut">
               <a:rPr lang="en-ZA" smtClean="0"/>
-              <a:t>2026/04/28</a:t>
+              <a:t>2026/05/14</a:t>
             </a:fld>
             <a:endParaRPr lang="en-ZA"/>
           </a:p>
@@ -2443,7 +2729,7 @@
           <a:p>
             <a:fld id="{D3997BC2-908B-4AE2-B66B-0BE82B2F56FB}" type="datetimeFigureOut">
               <a:rPr lang="en-ZA" smtClean="0"/>
-              <a:t>2026/04/28</a:t>
+              <a:t>2026/05/14</a:t>
             </a:fld>
             <a:endParaRPr lang="en-ZA"/>
           </a:p>
@@ -2756,7 +3042,7 @@
           <a:p>
             <a:fld id="{D3997BC2-908B-4AE2-B66B-0BE82B2F56FB}" type="datetimeFigureOut">
               <a:rPr lang="en-ZA" smtClean="0"/>
-              <a:t>2026/04/28</a:t>
+              <a:t>2026/05/14</a:t>
             </a:fld>
             <a:endParaRPr lang="en-ZA"/>
           </a:p>
@@ -3045,7 +3331,7 @@
           <a:p>
             <a:fld id="{D3997BC2-908B-4AE2-B66B-0BE82B2F56FB}" type="datetimeFigureOut">
               <a:rPr lang="en-ZA" smtClean="0"/>
-              <a:t>2026/04/28</a:t>
+              <a:t>2026/05/14</a:t>
             </a:fld>
             <a:endParaRPr lang="en-ZA"/>
           </a:p>
@@ -3288,7 +3574,7 @@
           <a:p>
             <a:fld id="{D3997BC2-908B-4AE2-B66B-0BE82B2F56FB}" type="datetimeFigureOut">
               <a:rPr lang="en-ZA" smtClean="0"/>
-              <a:t>2026/04/28</a:t>
+              <a:t>2026/05/14</a:t>
             </a:fld>
             <a:endParaRPr lang="en-ZA"/>
           </a:p>
@@ -6164,10 +6450,18 @@
             </a:r>
           </a:p>
           <a:p>
-            <a:pPr marL="0" indent="0">
-              <a:buNone/>
-            </a:pPr>
-            <a:endParaRPr lang="en-US" sz="2400" dirty="0"/>
+            <a:r>
+              <a:rPr lang="en-US" sz="2400" dirty="0"/>
+              <a:t>Leakage removed (</a:t>
+            </a:r>
+            <a:r>
+              <a:rPr lang="en-US" sz="2400" dirty="0" err="1"/>
+              <a:t>DowntimeType</a:t>
+            </a:r>
+            <a:r>
+              <a:rPr lang="en-US" sz="2400" dirty="0"/>
+              <a:t>), Class order forced (levels = c("0","1")) ,Numeric conversion + median imputation were also used.</a:t>
+            </a:r>
           </a:p>
           <a:p>
             <a:pPr marL="0" indent="0">
@@ -6925,20 +7219,7 @@
             </a:pPr>
             <a:r>
               <a:rPr lang="en-US" dirty="0"/>
-              <a:t>- Random Forest (ensemble model for improved accuracy)</a:t>
-            </a:r>
-          </a:p>
-          <a:p>
-            <a:pPr>
-              <a:lnSpc>
-                <a:spcPct val="150000"/>
-              </a:lnSpc>
-              <a:buFontTx/>
-              <a:buChar char="-"/>
-            </a:pPr>
-            <a:r>
-              <a:rPr lang="en-US" dirty="0"/>
-              <a:t>Naive Bayes (probabilistic independence model)</a:t>
+              <a:t>- Naive Bayes (probabilistic independence model)</a:t>
             </a:r>
             <a:endParaRPr lang="en-US" b="1" dirty="0"/>
           </a:p>
@@ -7625,39 +7906,57 @@
             </a:r>
           </a:p>
           <a:p>
-            <a:pPr marL="0" indent="0">
-              <a:buNone/>
+            <a:pPr>
+              <a:buFontTx/>
+              <a:buChar char="-"/>
             </a:pPr>
             <a:r>
-              <a:rPr lang="en-US" sz="3200" dirty="0"/>
-              <a:t>- Random Forest achieved highest AUC (best performance)</a:t>
-            </a:r>
-          </a:p>
-          <a:p>
-            <a:pPr marL="0" indent="0">
-              <a:buNone/>
+              <a:rPr lang="en-US" sz="2400" b="1" dirty="0"/>
+              <a:t>The Decision Tree achieved the highest AUC</a:t>
+            </a:r>
+            <a:r>
+              <a:rPr lang="en-US" sz="1900" b="1" dirty="0"/>
+              <a:t> - </a:t>
+            </a:r>
+            <a:r>
+              <a:rPr lang="en-US" sz="1900" dirty="0"/>
+              <a:t>demonstrating the strongest predictive performance on the held‑out test set.</a:t>
+            </a:r>
+          </a:p>
+          <a:p>
+            <a:pPr>
+              <a:buFontTx/>
+              <a:buChar char="-"/>
             </a:pPr>
             <a:r>
-              <a:rPr lang="en-US" sz="3200" dirty="0"/>
-              <a:t>- Decision Tree showed mild overfitting</a:t>
-            </a:r>
-          </a:p>
-          <a:p>
-            <a:pPr marL="0" indent="0">
-              <a:buNone/>
+              <a:rPr lang="en-US" sz="2400" b="1" dirty="0"/>
+              <a:t>Logistic Regression showed lower performance</a:t>
+            </a:r>
+            <a:r>
+              <a:rPr lang="en-US" sz="1900" dirty="0"/>
+              <a:t>, as its linear structure limited its ability to capture non‑linear and threshold‑based patterns in maintenance </a:t>
+            </a:r>
+            <a:r>
+              <a:rPr lang="en-US" sz="1900" dirty="0" err="1"/>
+              <a:t>behaviour</a:t>
+            </a:r>
+            <a:r>
+              <a:rPr lang="en-US" sz="1900" dirty="0"/>
+              <a:t>.</a:t>
+            </a:r>
+          </a:p>
+          <a:p>
+            <a:pPr>
+              <a:buFontTx/>
+              <a:buChar char="-"/>
             </a:pPr>
             <a:r>
-              <a:rPr lang="en-US" sz="3200" dirty="0"/>
-              <a:t>- Logistic Regression was stable but less flexible</a:t>
-            </a:r>
-          </a:p>
-          <a:p>
-            <a:pPr marL="0" indent="0">
-              <a:buNone/>
-            </a:pPr>
-            <a:r>
-              <a:rPr lang="en-US" sz="3200" dirty="0"/>
-              <a:t>- Naive Bayes performed lowest due to independence assumptions</a:t>
+              <a:rPr lang="en-US" sz="2400" b="1" dirty="0"/>
+              <a:t>Naïve Bayes performed poorest </a:t>
+            </a:r>
+            <a:r>
+              <a:rPr lang="en-US" sz="1900" dirty="0"/>
+              <a:t>-  likely due to violations of the conditional independence assumption after data cleaning and leakage removal.</a:t>
             </a:r>
           </a:p>
         </p:txBody>
@@ -7876,7 +8175,7 @@
           <p:nvPr/>
         </p:nvPicPr>
         <p:blipFill>
-          <a:blip r:embed="rId2" cstate="print">
+          <a:blip r:embed="rId3" cstate="print">
             <a:extLst>
               <a:ext uri="{28A0092B-C50C-407E-A947-70E740481C1C}">
                 <a14:useLocalDpi xmlns:a14="http://schemas.microsoft.com/office/drawing/2010/main" val="0"/>
@@ -8306,7 +8605,7 @@
           <a:p>
             <a:r>
               <a:rPr lang="en-US" dirty="0"/>
-              <a:t>Top predictive features (Random Forest):</a:t>
+              <a:t>Top predictive features (Naïve Bayes):</a:t>
             </a:r>
           </a:p>
           <a:p>
@@ -8365,39 +8664,58 @@
             </a:r>
           </a:p>
           <a:p>
-            <a:pPr>
+            <a:pPr marL="0" indent="0" fontAlgn="t">
+              <a:buNone/>
+            </a:pPr>
+            <a:r>
+              <a:rPr lang="en-US" sz="2000" b="1" dirty="0"/>
+              <a:t>ROC Curve Insight</a:t>
+            </a:r>
+          </a:p>
+          <a:p>
+            <a:pPr fontAlgn="t">
               <a:buFont typeface="Wingdings" panose="05000000000000000000" pitchFamily="2" charset="2"/>
               <a:buChar char="ü"/>
             </a:pPr>
             <a:r>
-              <a:rPr lang="en-US" dirty="0"/>
-              <a:t>Random Forest provided the best balance of accuracy and </a:t>
-            </a:r>
-            <a:r>
-              <a:rPr lang="en-US" dirty="0" err="1"/>
-              <a:t>generalisation</a:t>
-            </a:r>
-            <a:r>
-              <a:rPr lang="en-US" dirty="0"/>
-              <a:t>. Feature engineering significantly improved predictive power for maintenance classification.</a:t>
-            </a:r>
-          </a:p>
-          <a:p>
-            <a:pPr>
+              <a:rPr lang="en-US" sz="2000" dirty="0"/>
+              <a:t>Decision Tree shows the strongest ROC performance.</a:t>
+            </a:r>
+          </a:p>
+          <a:p>
+            <a:pPr fontAlgn="t">
               <a:buFont typeface="Wingdings" panose="05000000000000000000" pitchFamily="2" charset="2"/>
               <a:buChar char="ü"/>
             </a:pPr>
             <a:r>
-              <a:rPr lang="en-US" dirty="0"/>
-              <a:t>Time + severity + operational context drive maintenance needs &amp; save companies money</a:t>
-            </a:r>
-          </a:p>
-          <a:p>
-            <a:pPr>
+              <a:rPr lang="en-US" sz="2000" dirty="0"/>
+              <a:t>High sensitivity achieved with better separation of classes.</a:t>
+            </a:r>
+          </a:p>
+          <a:p>
+            <a:pPr fontAlgn="t">
               <a:buFont typeface="Wingdings" panose="05000000000000000000" pitchFamily="2" charset="2"/>
               <a:buChar char="ü"/>
             </a:pPr>
-            <a:endParaRPr lang="en-US" dirty="0"/>
+            <a:r>
+              <a:rPr lang="en-US" sz="2000" dirty="0"/>
+              <a:t>Logistic Regression offers moderate discrimination.</a:t>
+            </a:r>
+          </a:p>
+          <a:p>
+            <a:pPr fontAlgn="t">
+              <a:buFont typeface="Wingdings" panose="05000000000000000000" pitchFamily="2" charset="2"/>
+              <a:buChar char="ü"/>
+            </a:pPr>
+            <a:r>
+              <a:rPr lang="en-US" sz="2000" dirty="0"/>
+              <a:t>Naïve Bayes performs close to random guessing.</a:t>
+            </a:r>
+            <a:endParaRPr lang="en-US" b="1" dirty="0">
+              <a:solidFill>
+                <a:srgbClr val="C00000"/>
+              </a:solidFill>
+            </a:endParaRPr>
           </a:p>
         </p:txBody>
       </p:sp>
@@ -8564,6 +8882,36 @@
           </a:p>
         </p:txBody>
       </p:sp>
+      <p:pic>
+        <p:nvPicPr>
+          <p:cNvPr id="9" name="Picture 8">
+            <a:extLst>
+              <a:ext uri="{FF2B5EF4-FFF2-40B4-BE49-F238E27FC236}">
+                <a16:creationId xmlns:a16="http://schemas.microsoft.com/office/drawing/2014/main" id="{8C3FF170-DC08-9C97-E16C-912654BEB6C1}"/>
+              </a:ext>
+            </a:extLst>
+          </p:cNvPr>
+          <p:cNvPicPr>
+            <a:picLocks noChangeAspect="1"/>
+          </p:cNvPicPr>
+          <p:nvPr/>
+        </p:nvPicPr>
+        <p:blipFill>
+          <a:blip r:embed="rId4"/>
+          <a:stretch>
+            <a:fillRect/>
+          </a:stretch>
+        </p:blipFill>
+        <p:spPr>
+          <a:xfrm>
+            <a:off x="5653951" y="1036101"/>
+            <a:ext cx="6309907" cy="4244708"/>
+          </a:xfrm>
+          <a:prstGeom prst="rect">
+            <a:avLst/>
+          </a:prstGeom>
+        </p:spPr>
+      </p:pic>
     </p:spTree>
     <p:extLst>
       <p:ext uri="{BB962C8B-B14F-4D97-AF65-F5344CB8AC3E}">

</xml_diff>

<commit_message>
updated comments and cleaned up code a litle bit
</commit_message>
<xml_diff>
--- a/Binary Classification 606.pptx
+++ b/Binary Classification 606.pptx
@@ -202,7 +202,7 @@
           <a:p>
             <a:fld id="{F94E02D4-7CEE-4426-B842-C52CC7EAF1AF}" type="datetimeFigureOut">
               <a:rPr lang="en-ZA" smtClean="0"/>
-              <a:t>2026/05/14</a:t>
+              <a:t>2026/05/15</a:t>
             </a:fld>
             <a:endParaRPr lang="en-ZA"/>
           </a:p>
@@ -905,7 +905,7 @@
           <a:p>
             <a:fld id="{D3997BC2-908B-4AE2-B66B-0BE82B2F56FB}" type="datetimeFigureOut">
               <a:rPr lang="en-ZA" smtClean="0"/>
-              <a:t>2026/05/14</a:t>
+              <a:t>2026/05/15</a:t>
             </a:fld>
             <a:endParaRPr lang="en-ZA"/>
           </a:p>
@@ -1105,7 +1105,7 @@
           <a:p>
             <a:fld id="{D3997BC2-908B-4AE2-B66B-0BE82B2F56FB}" type="datetimeFigureOut">
               <a:rPr lang="en-ZA" smtClean="0"/>
-              <a:t>2026/05/14</a:t>
+              <a:t>2026/05/15</a:t>
             </a:fld>
             <a:endParaRPr lang="en-ZA"/>
           </a:p>
@@ -1315,7 +1315,7 @@
           <a:p>
             <a:fld id="{D3997BC2-908B-4AE2-B66B-0BE82B2F56FB}" type="datetimeFigureOut">
               <a:rPr lang="en-ZA" smtClean="0"/>
-              <a:t>2026/05/14</a:t>
+              <a:t>2026/05/15</a:t>
             </a:fld>
             <a:endParaRPr lang="en-ZA"/>
           </a:p>
@@ -1515,7 +1515,7 @@
           <a:p>
             <a:fld id="{D3997BC2-908B-4AE2-B66B-0BE82B2F56FB}" type="datetimeFigureOut">
               <a:rPr lang="en-ZA" smtClean="0"/>
-              <a:t>2026/05/14</a:t>
+              <a:t>2026/05/15</a:t>
             </a:fld>
             <a:endParaRPr lang="en-ZA"/>
           </a:p>
@@ -1791,7 +1791,7 @@
           <a:p>
             <a:fld id="{D3997BC2-908B-4AE2-B66B-0BE82B2F56FB}" type="datetimeFigureOut">
               <a:rPr lang="en-ZA" smtClean="0"/>
-              <a:t>2026/05/14</a:t>
+              <a:t>2026/05/15</a:t>
             </a:fld>
             <a:endParaRPr lang="en-ZA"/>
           </a:p>
@@ -2059,7 +2059,7 @@
           <a:p>
             <a:fld id="{D3997BC2-908B-4AE2-B66B-0BE82B2F56FB}" type="datetimeFigureOut">
               <a:rPr lang="en-ZA" smtClean="0"/>
-              <a:t>2026/05/14</a:t>
+              <a:t>2026/05/15</a:t>
             </a:fld>
             <a:endParaRPr lang="en-ZA"/>
           </a:p>
@@ -2474,7 +2474,7 @@
           <a:p>
             <a:fld id="{D3997BC2-908B-4AE2-B66B-0BE82B2F56FB}" type="datetimeFigureOut">
               <a:rPr lang="en-ZA" smtClean="0"/>
-              <a:t>2026/05/14</a:t>
+              <a:t>2026/05/15</a:t>
             </a:fld>
             <a:endParaRPr lang="en-ZA"/>
           </a:p>
@@ -2616,7 +2616,7 @@
           <a:p>
             <a:fld id="{D3997BC2-908B-4AE2-B66B-0BE82B2F56FB}" type="datetimeFigureOut">
               <a:rPr lang="en-ZA" smtClean="0"/>
-              <a:t>2026/05/14</a:t>
+              <a:t>2026/05/15</a:t>
             </a:fld>
             <a:endParaRPr lang="en-ZA"/>
           </a:p>
@@ -2729,7 +2729,7 @@
           <a:p>
             <a:fld id="{D3997BC2-908B-4AE2-B66B-0BE82B2F56FB}" type="datetimeFigureOut">
               <a:rPr lang="en-ZA" smtClean="0"/>
-              <a:t>2026/05/14</a:t>
+              <a:t>2026/05/15</a:t>
             </a:fld>
             <a:endParaRPr lang="en-ZA"/>
           </a:p>
@@ -3042,7 +3042,7 @@
           <a:p>
             <a:fld id="{D3997BC2-908B-4AE2-B66B-0BE82B2F56FB}" type="datetimeFigureOut">
               <a:rPr lang="en-ZA" smtClean="0"/>
-              <a:t>2026/05/14</a:t>
+              <a:t>2026/05/15</a:t>
             </a:fld>
             <a:endParaRPr lang="en-ZA"/>
           </a:p>
@@ -3331,7 +3331,7 @@
           <a:p>
             <a:fld id="{D3997BC2-908B-4AE2-B66B-0BE82B2F56FB}" type="datetimeFigureOut">
               <a:rPr lang="en-ZA" smtClean="0"/>
-              <a:t>2026/05/14</a:t>
+              <a:t>2026/05/15</a:t>
             </a:fld>
             <a:endParaRPr lang="en-ZA"/>
           </a:p>
@@ -3574,7 +3574,7 @@
           <a:p>
             <a:fld id="{D3997BC2-908B-4AE2-B66B-0BE82B2F56FB}" type="datetimeFigureOut">
               <a:rPr lang="en-ZA" smtClean="0"/>
-              <a:t>2026/05/14</a:t>
+              <a:t>2026/05/15</a:t>
             </a:fld>
             <a:endParaRPr lang="en-ZA"/>
           </a:p>
@@ -8605,7 +8605,7 @@
           <a:p>
             <a:r>
               <a:rPr lang="en-US" dirty="0"/>
-              <a:t>Top predictive features (Naïve Bayes):</a:t>
+              <a:t>Top predictive features (Decision Tree):</a:t>
             </a:r>
           </a:p>
           <a:p>
@@ -8904,8 +8904,8 @@
         </p:blipFill>
         <p:spPr>
           <a:xfrm>
-            <a:off x="5653951" y="1036101"/>
-            <a:ext cx="6309907" cy="4244708"/>
+            <a:off x="6447692" y="1036101"/>
+            <a:ext cx="5516166" cy="4244708"/>
           </a:xfrm>
           <a:prstGeom prst="rect">
             <a:avLst/>

</xml_diff>